<commit_message>
Deck: front-load the two-repository proposal; add metadata/content repository and mission-sponsor slides
- New early slides: What we propose (two repositories, Fig 1), The metadata repository (inventory/utilization/performance/ROI), The content repository (system of record)
- Mission sponsor and next steps slide (phased build, pilot, predictions as acceptance tests)
- Sponsor placeholder on title; ROI slide tied to the metadata repository
- 24 slides

Co-Authored-By: Claude Opus 4.8 <noreply@anthropic.com>
</commit_message>
<xml_diff>
--- a/papers/ai-metadata-session-data-repository/AI_Metadata_Repository_Briefing.pptx
+++ b/papers/ai-metadata-session-data-repository/AI_Metadata_Repository_Briefing.pptx
@@ -26,6 +26,9 @@
     <p:sldId id="274" r:id="rId26"/>
     <p:sldId id="275" r:id="rId27"/>
     <p:sldId id="276" r:id="rId28"/>
+    <p:sldId id="277" r:id="rId29"/>
+    <p:sldId id="278" r:id="rId30"/>
+    <p:sldId id="279" r:id="rId31"/>
   </p:sldIdLst>
   <p:sldSz cx="12191695" cy="6858000" type="screen4x3"/>
   <p:notesSz cx="6858000" cy="9144000"/>
@@ -592,7 +595,7 @@
           <a:lstStyle/>
           <a:p>
             <a:r>
-              <a:t>A crucial design decision: measures of performance, effectiveness, and KPIs are not properties of the architecture. They are the objectives of the organization, defined in layers, corporate strategy at the top, division and then workflow below. Each layer names its own measures. The architecture does not impose a fixed metric set, and it should not, because objectives change. Its job is to collect, detect, catalog, and store the outcomes those measures are computed from, and to roll them up from the workflow where they occur to the strategic objective they serve. On top of the standard families it adds measures a fixed dashboard would miss: how skillfully the workforce directs and checks the AI, the model's reliability and drift, and the gap between how much people trust the model and how reliable it actually is.</a:t>
+              <a:t>The distinction that makes this precise is monitoring versus observability. Monitoring instruments a system against questions its designers already hold: fixed metrics, thresholds, dashboards. It answers known unknowns, and it is useful. Most AI operational tooling on the market today is monitoring: it traces calls and scores them against evaluations chosen in advance. Observability is different: it records behavior at enough fidelity that a question nobody anticipated at instrumentation time can still be answered later by interrogating the record. Because AI failure modes emerge, the questions that will matter most are exactly the ones nobody thought to declare. So what an enterprise needs is an observability substrate, and every design choice that follows, immutability, granularity, provenance, retention, is justified by whether it keeps a future, unspecified question answerable.</a:t>
             </a:r>
           </a:p>
         </p:txBody>
@@ -662,7 +665,7 @@
           <a:lstStyle/>
           <a:p>
             <a:r>
-              <a:t>The architecture is a funded investment, and like any portfolio investment it has to justify its cost. Because the record makes both cost and outcome measurable, return becomes calculable rather than asserted. Cost we know from the event record. Outcome value we know from the outcome repository, and because each outcome links to the interactions that produced it, we can attribute value to the work that earned it. The question an executive most wants answered, how far does AI multiply what our workforce produces, becomes a computed quantity: output with AI set against output without, tracked over time. And it is neutral to sign. The same record shows where over-reliance is quietly degrading skills our workforce would otherwise keep, which is a cost a naive productivity number hides.</a:t>
+              <a:t>If an event's meaning is knowable only through its cause and its trajectory, then the unit of capture cannot be a flat log line. Each interaction is stored as one immutable event that records both the exchanged text and the conditions that produced it: the system prompt, the decoding parameters, the model version, the tool calls and results, and the human interactions, the edits, acceptances, and rejections. A hallucination produced at a high temperature under a permissive prompt is a different event, with a different cause, from the same words produced under a constraining one. Events are immutable and linked to their antecedents and consequents, so a cascade can be traversed rather than guessed. And each record is kept twice: a raw, append-only form that is never rewritten, and a structured, queryable form. A later re-classification adds a label; it never alters the original.</a:t>
             </a:r>
           </a:p>
         </p:txBody>
@@ -732,7 +735,7 @@
           <a:lstStyle/>
           <a:p>
             <a:r>
-              <a:t>For harm we borrow a lifecycle from public-health adverse-event surveillance, because the shape is the same. A single failure is an instance, and its importance is not evident at the moment it occurs, because impact is a function of trajectory. Repeated instances form an incidence we can track. Some trace to a cause; some cascade downstream. A mitigation applied after detection has an efficacy that is itself measurable, as a change in incidence across the dated boundary where we applied it. And a mitigation that works and gets moved upstream becomes prevention. Every step here is a query over the linked record, not an inference from a point-in-time log. This is how we turn hallucination from an anecdote into something managed on a curve.</a:t>
+              <a:t>A crucial design decision: measures of performance, effectiveness, and KPIs are not properties of the architecture. They are the objectives of the organization, defined in layers, corporate strategy at the top, division and then workflow below. Each layer names its own measures. The architecture does not impose a fixed metric set, and it should not, because objectives change. Its job is to collect, detect, catalog, and store the outcomes those measures are computed from, and to roll them up from the workflow where they occur to the strategic objective they serve. On top of the standard families it adds measures a fixed dashboard would miss: how skillfully the workforce directs and checks the AI, the model's reliability and drift, and the gap between how much people trust the model and how reliable it actually is.</a:t>
             </a:r>
           </a:p>
         </p:txBody>
@@ -802,7 +805,7 @@
           <a:lstStyle/>
           <a:p>
             <a:r>
-              <a:t>Hallucination is not one thing, and detecting it requires knowing which form is in play. The taxonomy has fabrication, overconfidence and misrepresentation, staleness, context loss, attribution error, scope and instruction divergence, and agentic or tool-use failure. Each category is detectable only from particular captured fields, which is precisely why the data model records the generating conditions and the provenance and not just the output. Alongside these, though they are not hallucinations, we also track refusal and over-restriction, where the model declines legitimate work and the harm is a withheld benefit, and the inverse, where it complies with something it should have declined. The most damaging form is fabrication: fiction presented in the form of established fact. The architectural defense is provenance. The repository does not stop the model from fabricating; it stops a fabrication from silently becoming part of our fact base.</a:t>
+              <a:t>The architecture is a funded investment, and like any portfolio investment it has to justify its cost. Because the record makes both cost and outcome measurable, return becomes calculable rather than asserted. Cost we know from the event record. Outcome value we know from the outcome repository, and because each outcome links to the interactions that produced it, we can attribute value to the work that earned it. The question an executive most wants answered, how far does AI multiply what our workforce produces, becomes a computed quantity: output with AI set against output without, tracked over time. And it is neutral to sign. The same record shows where over-reliance is quietly degrading skills our workforce would otherwise keep, which is a cost a naive productivity number hides.</a:t>
             </a:r>
           </a:p>
         </p:txBody>
@@ -872,7 +875,7 @@
           <a:lstStyle/>
           <a:p>
             <a:r>
-              <a:t>This is the risk surface leadership feels most directly, and it is where the whole architecture pays off at once. When an AI-induced harm occurs, the harm is not the end of the event. It opens an investigation we are obliged to conduct, and the questions are forensic: what was produced, what triggered it, what caused it, how far did it spread, who and what is accountable, and how do we prevent a recurrence. None of these can be answered after the fact for an interaction nobody captured. The record is the forensic substrate. The loop on this slide is the workflow: reconstruct the trigger and conditions, attribute the event, trace its scope and cascade, prescribe a guardrail matched to the cause, and measure whether the guardrail worked. Let me take the two hardest parts, attribution and guardrails, on the next slides.</a:t>
+              <a:t>For harm we borrow a lifecycle from public-health adverse-event surveillance, because the shape is the same. A single failure is an instance, and its importance is not evident at the moment it occurs, because impact is a function of trajectory. Repeated instances form an incidence we can track. Some trace to a cause; some cascade downstream. A mitigation applied after detection has an efficacy that is itself measurable, as a change in incidence across the dated boundary where we applied it. And a mitigation that works and gets moved upstream becomes prevention. Every step here is a query over the linked record, not an inference from a point-in-time log. This is how we turn hallucination from an anecdote into something managed on a curve.</a:t>
             </a:r>
           </a:p>
         </p:txBody>
@@ -942,7 +945,7 @@
           <a:lstStyle/>
           <a:p>
             <a:r>
-              <a:t>A forensic account has to attribute the harm, and attribution starts by separating what the human did from what the AI did. The record supports that because it captures both sides as distinct, linked events. From that we can tell two cases apart that we must never conflate. In the first, the AI actor is the source: the model fabricated, misrepresented, or took an unsafe autonomous action outside its authorized scope. That is the rogue or agentic case. In the second, the human actor is the source: a person directed the AI to act against the organization, and the AI was merely the instrument. That is insider misuse, and its signature is not a model error at all, it is a pattern of instruction and use, extraction at volume, probing of scope or permission. The same record grounds both findings, and only the record lets us distinguish them, because a human actor's intent is legible only through the sequence of instructions the record preserves.</a:t>
+              <a:t>Hallucination is not one thing, and detecting it requires knowing which form is in play. The taxonomy has fabrication, overconfidence and misrepresentation, staleness, context loss, attribution error, scope and instruction divergence, and agentic or tool-use failure. Each category is detectable only from particular captured fields, which is precisely why the data model records the generating conditions and the provenance and not just the output. Alongside these, though they are not hallucinations, we also track refusal and over-restriction, where the model declines legitimate work and the harm is a withheld benefit, and the inverse, where it complies with something it should have declined. The most damaging form is fabrication: fiction presented in the form of established fact. The architectural defense is provenance. The repository does not stop the model from fabricating; it stops a fabrication from silently becoming part of our fact base.</a:t>
             </a:r>
           </a:p>
         </p:txBody>
@@ -1012,7 +1015,7 @@
           <a:lstStyle/>
           <a:p>
             <a:r>
-              <a:t>An investigation is not done when it explains a harm. Its purpose is to prevent the next one, and its output is a guardrail chosen to fit the cause it found. If the cause was a permissive system prompt, the guardrail is prompt engineering. If it was an unchecked input or unscreened output, it is validation. If a human review would have caught it, it is a human-in-the-loop gate, and the record also shows when a gate existed but was not enforced. If an agent took an unsafe action, it is a tool or permission constraint. If the cause was over-trust or an unrecognized fabrication, the guardrail is workforce training. And if it was a model change, it is version control. The key point for accountability: each guardrail is itself recorded and dated, and its efficacy is measured by the same machinery that detected the harm. A guardrail whose efficacy the record cannot demonstrate is, for accountability purposes, indistinguishable from no guardrail at all.</a:t>
+              <a:t>This is the risk surface leadership feels most directly, and it is where the whole architecture pays off at once. When an AI-induced harm occurs, the harm is not the end of the event. It opens an investigation we are obliged to conduct, and the questions are forensic: what was produced, what triggered it, what caused it, how far did it spread, who and what is accountable, and how do we prevent a recurrence. None of these can be answered after the fact for an interaction nobody captured. The record is the forensic substrate. The loop on this slide is the workflow: reconstruct the trigger and conditions, attribute the event, trace its scope and cascade, prescribe a guardrail matched to the cause, and measure whether the guardrail worked. Let me take the two hardest parts, attribution and guardrails, on the next slides.</a:t>
             </a:r>
           </a:p>
         </p:txBody>
@@ -1082,7 +1085,7 @@
           <a:lstStyle/>
           <a:p>
             <a:r>
-              <a:t>Two connected points. First, correctness is not the only bar. An AI output can be factually right and still violate an internal policy, a law, a professional standard, or a required procedure. So we evaluate AI use against each class of obligation that applies, and that is only possible over a record that holds the output together with its conditions and its downstream use. A violation is just one of the negative outcomes we already track. Second, trust. People tend to treat a fluent, confident model as an expert and extend it trust it has not earned. The goal is not maximal trust or minimal trust, it is calibrated trust: reliance that tracks demonstrated reliability. That requires two things the record provides. Trust has to be earned, which means measured, and it has to be curated, which means the provenance and the model's track record are surfaced to the user at the moment they rely on it.</a:t>
+              <a:t>A forensic account has to attribute the harm, and attribution starts by separating what the human did from what the AI did. The record supports that because it captures both sides as distinct, linked events. From that we can tell two cases apart that we must never conflate. In the first, the AI actor is the source: the model fabricated, misrepresented, or took an unsafe autonomous action outside its authorized scope. That is the rogue or agentic case. In the second, the human actor is the source: a person directed the AI to act against the organization, and the AI was merely the instrument. That is insider misuse, and its signature is not a model error at all, it is a pattern of instruction and use, extraction at volume, probing of scope or permission. The same record grounds both findings, and only the record lets us distinguish them, because a human actor's intent is legible only through the sequence of instructions the record preserves.</a:t>
             </a:r>
           </a:p>
         </p:txBody>
@@ -1152,7 +1155,7 @@
           <a:lstStyle/>
           <a:p>
             <a:r>
-              <a:t>Operationally it is a client-side system that captures at the points of AI use, an API gateway or proxy, hooks in agent frameworks, connectors to chat and development tools, and serves reporting back. It monitors its own health, because an observability system has to be observable; an outage in capture should be seen, not mistaken for quiet. On topology there is a choice: converge the channels into one store with logical separation where that is enough, or isolate systems where a separation must be guaranteed, for instance keeping live operations apart from drills, or fencing a sensitive product line. And there is a deliberate future leg: controlled continuity, resuming a session from a curated summary drawn from the record, and workflow-lane isolation, so a single user's unrelated tasks never bleed into one another, because uncontrolled context mixing is itself a source of error in these systems.</a:t>
+              <a:t>An investigation is not done when it explains a harm. Its purpose is to prevent the next one, and its output is a guardrail chosen to fit the cause it found. If the cause was a permissive system prompt, the guardrail is prompt engineering. If it was an unchecked input or unscreened output, it is validation. If a human review would have caught it, it is a human-in-the-loop gate, and the record also shows when a gate existed but was not enforced. If an agent took an unsafe action, it is a tool or permission constraint. If the cause was over-trust or an unrecognized fabrication, the guardrail is workforce training. And if it was a model change, it is version control. The key point for accountability: each guardrail is itself recorded and dated, and its efficacy is measured by the same machinery that detected the harm. A guardrail whose efficacy the record cannot demonstrate is, for accountability purposes, indistinguishable from no guardrail at all.</a:t>
             </a:r>
           </a:p>
         </p:txBody>
@@ -1222,7 +1225,7 @@
           <a:lstStyle/>
           <a:p>
             <a:r>
-              <a:t>The record is powerful because it is complete, and sensitive for the same reason, so governance is built into the design rather than bolted on. Segregating the stores by sensitivity is the first control: the person who reports on performance does not thereby gain the organization's risk and insider-threat records. Identity is pseudonymous by default, so we measure roles and workflows, not named people, and re-identifying someone is a governed, recorded exception for a stated purpose such as a security case. The same record is security telemetry, so insider-threat monitoring is legitimate, but it is bounded by purpose, by access, and by proportionality, because surveillance changes the behavior it observes. And crucially for compliance, this architecture supplies exactly the record that the NIST AI Risk Management Framework, ISO 42001 and 23894, the EU AI Act's logging obligations, and the OWASP LLM Top 10 all presume but do not themselves provide.</a:t>
+              <a:t>Two connected points. First, correctness is not the only bar. An AI output can be factually right and still violate an internal policy, a law, a professional standard, or a required procedure. So we evaluate AI use against each class of obligation that applies, and that is only possible over a record that holds the output together with its conditions and its downstream use. A violation is just one of the negative outcomes we already track. Second, trust. People tend to treat a fluent, confident model as an expert and extend it trust it has not earned. The goal is not maximal trust or minimal trust, it is calibrated trust: reliance that tracks demonstrated reliability. That requires two things the record provides. Trust has to be earned, which means measured, and it has to be curated, which means the provenance and the model's track record are surfaced to the user at the moment they rely on it.</a:t>
             </a:r>
           </a:p>
         </p:txBody>
@@ -1362,7 +1365,7 @@
           <a:lstStyle/>
           <a:p>
             <a:r>
-              <a:t>Because this is a proposal, I am putting its claims on the record now as dated, falsifiable predictions, so that a deployed system later confirms or refutes them rather than us rationalizing after the fact. A few of them: hallucination recurrence should cluster in time around context-window saturation and compaction, not arrive at random. In a broadly captured corpus, the rate at which we discover new failure classes should rise with the corpus's age and size, precisely because detection is retrospective. Mitigation efficacy should be visible as an incidence change across the dated boundary where we applied it. Without a repository, an incident's true impact should be systematically underestimated, because the cascade is invisible at the moment it occurs. Guardrails placed upstream of a cause should outperform guardrails at the point of harm. And tightening a system prompt should trade over-refusal against under-refusal rather than improve both. These are testable, and that is the point.</a:t>
+              <a:t>Operationally it is a client-side system that captures at the points of AI use, an API gateway or proxy, hooks in agent frameworks, connectors to chat and development tools, and serves reporting back. It monitors its own health, because an observability system has to be observable; an outage in capture should be seen, not mistaken for quiet. On topology there is a choice: converge the channels into one store with logical separation where that is enough, or isolate systems where a separation must be guaranteed, for instance keeping live operations apart from drills, or fencing a sensitive product line. And there is a deliberate future leg: controlled continuity, resuming a session from a curated summary drawn from the record, and workflow-lane isolation, so a single user's unrelated tasks never bleed into one another, because uncontrolled context mixing is itself a source of error in these systems.</a:t>
             </a:r>
           </a:p>
         </p:txBody>
@@ -1432,6 +1435,216 @@
           <a:lstStyle/>
           <a:p>
             <a:r>
+              <a:t>The record is powerful because it is complete, and sensitive for the same reason, so governance is built into the design rather than bolted on. Segregating the stores by sensitivity is the first control: the person who reports on performance does not thereby gain the organization's risk and insider-threat records. Identity is pseudonymous by default, so we measure roles and workflows, not named people, and re-identifying someone is a governed, recorded exception for a stated purpose such as a security case. The same record is security telemetry, so insider-threat monitoring is legitimate, but it is bounded by purpose, by access, and by proportionality, because surveillance changes the behavior it observes. And crucially for compliance, this architecture supplies exactly the record that the NIST AI Risk Management Framework, ISO 42001 and 23894, the EU AI Act's logging obligations, and the OWASP LLM Top 10 all presume but do not themselves provide.</a:t>
+            </a:r>
+          </a:p>
+        </p:txBody>
+      </p:sp>
+      <p:sp>
+        <p:nvSpPr>
+          <p:cNvPr id="4" name="Slide Number Placeholder 3"/>
+          <p:cNvSpPr>
+            <a:spLocks noGrp="1"/>
+          </p:cNvSpPr>
+          <p:nvPr>
+            <p:ph type="sldNum" idx="5" sz="quarter"/>
+          </p:nvPr>
+        </p:nvSpPr>
+        <p:spPr/>
+      </p:sp>
+    </p:spTree>
+  </p:cSld>
+  <p:clrMapOvr>
+    <a:masterClrMapping/>
+  </p:clrMapOvr>
+</p:notes>
+</file>
+
+<file path=ppt/notesSlides/notesSlide22.xml><?xml version="1.0" encoding="utf-8"?>
+<p:notes xmlns:a="http://schemas.openxmlformats.org/drawingml/2006/main" xmlns:p="http://schemas.openxmlformats.org/presentationml/2006/main" xmlns:r="http://schemas.openxmlformats.org/officeDocument/2006/relationships">
+  <p:cSld>
+    <p:spTree>
+      <p:nvGrpSpPr>
+        <p:cNvPr id="1" name=""/>
+        <p:cNvGrpSpPr/>
+        <p:nvPr/>
+      </p:nvGrpSpPr>
+      <p:grpSpPr>
+        <a:xfrm>
+          <a:off x="0" y="0"/>
+          <a:ext cx="0" cy="0"/>
+          <a:chOff x="0" y="0"/>
+          <a:chExt cx="0" cy="0"/>
+        </a:xfrm>
+      </p:grpSpPr>
+      <p:sp>
+        <p:nvSpPr>
+          <p:cNvPr id="2" name="Slide Image Placeholder 1"/>
+          <p:cNvSpPr>
+            <a:spLocks noGrp="1"/>
+          </p:cNvSpPr>
+          <p:nvPr>
+            <p:ph type="sldImg" idx="2"/>
+          </p:nvPr>
+        </p:nvSpPr>
+        <p:spPr/>
+      </p:sp>
+      <p:sp>
+        <p:nvSpPr>
+          <p:cNvPr id="3" name="Notes Placeholder 2"/>
+          <p:cNvSpPr>
+            <a:spLocks noGrp="1"/>
+          </p:cNvSpPr>
+          <p:nvPr>
+            <p:ph type="body" idx="3" sz="quarter"/>
+          </p:nvPr>
+        </p:nvSpPr>
+        <p:spPr/>
+        <p:txBody>
+          <a:bodyPr/>
+          <a:lstStyle/>
+          <a:p>
+            <a:r>
+              <a:t>Because this is a proposal, I am putting its claims on the record now as dated, falsifiable predictions, so that a deployed system later confirms or refutes them rather than us rationalizing after the fact. A few of them: hallucination recurrence should cluster in time around context-window saturation and compaction, not arrive at random. In a broadly captured corpus, the rate at which we discover new failure classes should rise with the corpus's age and size, precisely because detection is retrospective. Mitigation efficacy should be visible as an incidence change across the dated boundary where we applied it. Without a repository, an incident's true impact should be systematically underestimated, because the cascade is invisible at the moment it occurs. Guardrails placed upstream of a cause should outperform guardrails at the point of harm. And tightening a system prompt should trade over-refusal against under-refusal rather than improve both. These are testable, and that is the point.</a:t>
+            </a:r>
+          </a:p>
+        </p:txBody>
+      </p:sp>
+      <p:sp>
+        <p:nvSpPr>
+          <p:cNvPr id="4" name="Slide Number Placeholder 3"/>
+          <p:cNvSpPr>
+            <a:spLocks noGrp="1"/>
+          </p:cNvSpPr>
+          <p:nvPr>
+            <p:ph type="sldNum" idx="5" sz="quarter"/>
+          </p:nvPr>
+        </p:nvSpPr>
+        <p:spPr/>
+      </p:sp>
+    </p:spTree>
+  </p:cSld>
+  <p:clrMapOvr>
+    <a:masterClrMapping/>
+  </p:clrMapOvr>
+</p:notes>
+</file>
+
+<file path=ppt/notesSlides/notesSlide23.xml><?xml version="1.0" encoding="utf-8"?>
+<p:notes xmlns:a="http://schemas.openxmlformats.org/drawingml/2006/main" xmlns:p="http://schemas.openxmlformats.org/presentationml/2006/main" xmlns:r="http://schemas.openxmlformats.org/officeDocument/2006/relationships">
+  <p:cSld>
+    <p:spTree>
+      <p:nvGrpSpPr>
+        <p:cNvPr id="1" name=""/>
+        <p:cNvGrpSpPr/>
+        <p:nvPr/>
+      </p:nvGrpSpPr>
+      <p:grpSpPr>
+        <a:xfrm>
+          <a:off x="0" y="0"/>
+          <a:ext cx="0" cy="0"/>
+          <a:chOff x="0" y="0"/>
+          <a:chExt cx="0" cy="0"/>
+        </a:xfrm>
+      </p:grpSpPr>
+      <p:sp>
+        <p:nvSpPr>
+          <p:cNvPr id="2" name="Slide Image Placeholder 1"/>
+          <p:cNvSpPr>
+            <a:spLocks noGrp="1"/>
+          </p:cNvSpPr>
+          <p:nvPr>
+            <p:ph type="sldImg" idx="2"/>
+          </p:nvPr>
+        </p:nvSpPr>
+        <p:spPr/>
+      </p:sp>
+      <p:sp>
+        <p:nvSpPr>
+          <p:cNvPr id="3" name="Notes Placeholder 2"/>
+          <p:cNvSpPr>
+            <a:spLocks noGrp="1"/>
+          </p:cNvSpPr>
+          <p:nvPr>
+            <p:ph type="body" idx="3" sz="quarter"/>
+          </p:nvPr>
+        </p:nvSpPr>
+        <p:spPr/>
+        <p:txBody>
+          <a:bodyPr/>
+          <a:lstStyle/>
+          <a:p>
+            <a:r>
+              <a:t>Here is what I am asking for and how we would proceed. I am proposing [Sponsoring Organization] as the mission sponsor for this architecture. What I need from the organization is its own data: the inventory of AI systems in use, the objective hierarchy each layer is accountable to, and the surfaces where AI is used so we know where to instrument. The build is phased and low-risk. We stand up the content repository first, because everything depends on capture. Then we derive the metadata repository from it. Then we add reporting and the return-on-investment view. We would not boil the ocean; we pilot on one bounded workflow, measure it against its own objectives, and widen only once it earns that. And the falsifiable predictions I just showed are not academic. They become the acceptance tests for the pilot: if the record does not make incidents, return, and mitigation efficacy measurable as predicted, we will know. I will bring the organization's specifics into the next version.</a:t>
+            </a:r>
+          </a:p>
+        </p:txBody>
+      </p:sp>
+      <p:sp>
+        <p:nvSpPr>
+          <p:cNvPr id="4" name="Slide Number Placeholder 3"/>
+          <p:cNvSpPr>
+            <a:spLocks noGrp="1"/>
+          </p:cNvSpPr>
+          <p:nvPr>
+            <p:ph type="sldNum" idx="5" sz="quarter"/>
+          </p:nvPr>
+        </p:nvSpPr>
+        <p:spPr/>
+      </p:sp>
+    </p:spTree>
+  </p:cSld>
+  <p:clrMapOvr>
+    <a:masterClrMapping/>
+  </p:clrMapOvr>
+</p:notes>
+</file>
+
+<file path=ppt/notesSlides/notesSlide24.xml><?xml version="1.0" encoding="utf-8"?>
+<p:notes xmlns:a="http://schemas.openxmlformats.org/drawingml/2006/main" xmlns:p="http://schemas.openxmlformats.org/presentationml/2006/main" xmlns:r="http://schemas.openxmlformats.org/officeDocument/2006/relationships">
+  <p:cSld>
+    <p:spTree>
+      <p:nvGrpSpPr>
+        <p:cNvPr id="1" name=""/>
+        <p:cNvGrpSpPr/>
+        <p:nvPr/>
+      </p:nvGrpSpPr>
+      <p:grpSpPr>
+        <a:xfrm>
+          <a:off x="0" y="0"/>
+          <a:ext cx="0" cy="0"/>
+          <a:chOff x="0" y="0"/>
+          <a:chExt cx="0" cy="0"/>
+        </a:xfrm>
+      </p:grpSpPr>
+      <p:sp>
+        <p:nvSpPr>
+          <p:cNvPr id="2" name="Slide Image Placeholder 1"/>
+          <p:cNvSpPr>
+            <a:spLocks noGrp="1"/>
+          </p:cNvSpPr>
+          <p:nvPr>
+            <p:ph type="sldImg" idx="2"/>
+          </p:nvPr>
+        </p:nvSpPr>
+        <p:spPr/>
+      </p:sp>
+      <p:sp>
+        <p:nvSpPr>
+          <p:cNvPr id="3" name="Notes Placeholder 2"/>
+          <p:cNvSpPr>
+            <a:spLocks noGrp="1"/>
+          </p:cNvSpPr>
+          <p:nvPr>
+            <p:ph type="body" idx="3" sz="quarter"/>
+          </p:nvPr>
+        </p:nvSpPr>
+        <p:spPr/>
+        <p:txBody>
+          <a:bodyPr/>
+          <a:lstStyle/>
+          <a:p>
+            <a:r>
               <a:t>To close, back to the one sentence. An organization cannot manage what it cannot see, and it cannot see its use of AI without a record of that use. Build that record and two things become true at once: the harms of AI become foreseeable, detectable, and mitigatable, and the value of AI, including how far it multiplies our people's output, becomes calculable. The same record serves both ends, which means an organization that keeps it can both defend against the liability of AI and prove its return, and an organization that does not can do neither. The one property of this decision I want to leave you with is that it is time-sensitive. Capture we do not start today is capture we can never recover, because there is no retrospective study of data nobody wrote down. The ask is simple: build the record first.</a:t>
             </a:r>
           </a:p>
@@ -1572,7 +1785,7 @@
           <a:lstStyle/>
           <a:p>
             <a:r>
-              <a:t>This is the slide that matters most to leadership, because it is about liability. An AI harm is not an act of god. It is foreseeable, because we know a prompt that works today can fail under a different input or a longer context. It is detectable, because the interaction that carried the fault can be examined. And it is mitigatable, because a fault we catch can be corrected before it spreads. Now put those together. An organization that could have foreseen, detected, and mitigated a harm, and did not, because it kept no record, owns the consequence. The record is what converts a foreseeable, detectable, mitigatable harm from a realized loss into a managed one. That is the difference between explaining an incident and being blindsided by it.</a:t>
+              <a:t>This is the proposal, and I want it on the table before I justify it. We are asking to build two repositories. The first is a content repository: the AI session data itself, every prompt, turn, tool call, and piece of context, preserved as the organization's system of record. The second is a metadata repository: everything we derive from that content in order to actually manage the AI, an inventory of what we have deployed, how much it is used, how well it performs, and what return the investment produces. Instrumented AI systems feed the content repository; the metadata repository is derived from it and segregated by sensitivity; and reporting draws from the metadata repository. Everything else in this talk is the argument for why this is the right shape and why it has to be built now. The purpose is management and return: to tell leadership what the AI investment bought and what it is worth.</a:t>
             </a:r>
           </a:p>
         </p:txBody>
@@ -1642,7 +1855,7 @@
           <a:lstStyle/>
           <a:p>
             <a:r>
-              <a:t>Three short scenarios, each a real failure shape. First, a system prompt that silently stops constraining the model when a customer phrases things a certain way, and the assistant states a policy we do not hold. Without the record, we learn when a customer acts on it. Second, the sharpest one: a fabricated figure that is indistinguishable from a sourced one, that moves into a report and then a decision. Provenance is the defense: a generated assertion stays distinguishable from an established fact. Third, a long session where the model forgets an earlier constraint and every later output looks locally reasonable and passes review on its own. In each case the difference between a managed event and a corporate loss is one thing: the record.</a:t>
+              <a:t>The metadata repository is the management vehicle, and it is where the return case lives. It holds four things leadership asks for and cannot get today. An inventory: what AI systems, models, and versions are actually deployed, and by whom. Utilization: how much we use AI, in sessions, tokens, and spend, broken down by team and workflow. Performance and effectiveness: whether the AI is doing useful work, measured by task success, rework, acceptance, and escalation. And return on investment: the cost we know from the record set against the outcome value we can attribute to AI use, reported at each layer of the objective hierarchy. It is segregated internally by sensitivity, so the risk and insider-threat metadata and the session-continuity metadata are governed on their own terms and not comingled with performance reporting. This is the repository that turns the AI budget from an act of faith into an account.</a:t>
             </a:r>
           </a:p>
         </p:txBody>
@@ -1712,7 +1925,7 @@
           <a:lstStyle/>
           <a:p>
             <a:r>
-              <a:t>This is the intellectual core, and it is about knowledge, not technology. Two claims. First, visibility is a precondition. A KPI, a measure of effectiveness, a hallucination rate, these are all functions computed over captured data. Where there is no capture, the function has no input and the question cannot be asked at all. Second, the behaviors worth measuring are not known at capture time. A new failure mode only becomes measurable after enough instances accumulate to form a pattern and after someone builds the lens to see it, and both of those happen after capture. Put the two together and you get an asymmetry: capture you omitted before a phenomenon emerged cannot be recovered afterward. There is no retrospective study of data nobody wrote down. So the rational policy is to capture earlier, wider, and at higher fidelity than any present question requires.</a:t>
+              <a:t>The content repository is the foundation the metadata repository is built on. It holds the raw session data itself: the system and user prompts, the model turns, the tool calls and results, and the context of each interaction. Each interaction is stored as one immutable event, together with the conditions that produced it, so it can be explained after the fact. Events are linked to their antecedents and consequents, and each is kept in two forms, a raw append-only form that is never rewritten and a structured, queryable form. The reason this matters: every number in the metadata repository, every risk detection, and every forensic reconstruction later in this talk is a query over this content. If it was not captured here, it cannot be measured, detected, or investigated anywhere downstream. That is why the content repository comes first.</a:t>
             </a:r>
           </a:p>
         </p:txBody>
@@ -1782,7 +1995,7 @@
           <a:lstStyle/>
           <a:p>
             <a:r>
-              <a:t>The distinction that makes this precise is monitoring versus observability. Monitoring instruments a system against questions its designers already hold: fixed metrics, thresholds, dashboards. It answers known unknowns, and it is useful. Most AI operational tooling on the market today is monitoring: it traces calls and scores them against evaluations chosen in advance. Observability is different: it records behavior at enough fidelity that a question nobody anticipated at instrumentation time can still be answered later by interrogating the record. Because AI failure modes emerge, the questions that will matter most are exactly the ones nobody thought to declare. So what an enterprise needs is an observability substrate, and every design choice that follows, immutability, granularity, provenance, retention, is justified by whether it keeps a future, unspecified question answerable.</a:t>
+              <a:t>This is the slide that matters most to leadership, because it is about liability. An AI harm is not an act of god. It is foreseeable, because we know a prompt that works today can fail under a different input or a longer context. It is detectable, because the interaction that carried the fault can be examined. And it is mitigatable, because a fault we catch can be corrected before it spreads. Now put those together. An organization that could have foreseen, detected, and mitigated a harm, and did not, because it kept no record, owns the consequence. The record is what converts a foreseeable, detectable, mitigatable harm from a realized loss into a managed one. That is the difference between explaining an incident and being blindsided by it.</a:t>
             </a:r>
           </a:p>
         </p:txBody>
@@ -1852,7 +2065,7 @@
           <a:lstStyle/>
           <a:p>
             <a:r>
-              <a:t>The architecture is simple at the top; its complexity is a drill-down. At the top it is a flow. The AI systems in use are instrumented. Their session content is stored. Metadata is derived from that content into a small set of repositories separated by sensitivity, performance in one, hallucination and risk in another, session continuity in a third. Outcomes and risks are drawn from that metadata, and the whole thing is reported to the organization, attributable by organization, product line, and purpose. The lower layers preserve and organize the record; the upper layers interrogate and report it. Keep that flow in mind, because the rest of the talk drills into each box.</a:t>
+              <a:t>Three short scenarios, each a real failure shape. First, a system prompt that silently stops constraining the model when a customer phrases things a certain way, and the assistant states a policy we do not hold. Without the record, we learn when a customer acts on it. Second, the sharpest one: a fabricated figure that is indistinguishable from a sourced one, that moves into a report and then a decision. Provenance is the defense: a generated assertion stays distinguishable from an established fact. Third, a long session where the model forgets an earlier constraint and every later output looks locally reasonable and passes review on its own. In each case the difference between a managed event and a corporate loss is one thing: the record.</a:t>
             </a:r>
           </a:p>
         </p:txBody>
@@ -1922,7 +2135,7 @@
           <a:lstStyle/>
           <a:p>
             <a:r>
-              <a:t>If an event's meaning is knowable only through its cause and its trajectory, then the unit of capture cannot be a flat log line. Each interaction is stored as one immutable event that records both the exchanged text and the conditions that produced it: the system prompt, the decoding parameters, the model version, the tool calls and results, and the human interactions, the edits, acceptances, and rejections. A hallucination produced at a high temperature under a permissive prompt is a different event, with a different cause, from the same words produced under a constraining one. Events are immutable and linked to their antecedents and consequents, so a cascade can be traversed rather than guessed. And each record is kept twice: a raw, append-only form that is never rewritten, and a structured, queryable form. A later re-classification adds a label; it never alters the original.</a:t>
+              <a:t>This is the intellectual core, and it is about knowledge, not technology. Two claims. First, visibility is a precondition. A KPI, a measure of effectiveness, a hallucination rate, these are all functions computed over captured data. Where there is no capture, the function has no input and the question cannot be asked at all. Second, the behaviors worth measuring are not known at capture time. A new failure mode only becomes measurable after enough instances accumulate to form a pattern and after someone builds the lens to see it, and both of those happen after capture. Put the two together and you get an asymmetry: capture you omitted before a phenomenon emerged cannot be recovered afterward. There is no retrospective study of data nobody wrote down. So the rational policy is to capture earlier, wider, and at higher fidelity than any present question requires.</a:t>
             </a:r>
           </a:p>
         </p:txBody>
@@ -4987,6 +5200,22 @@
               <a:t>Johnny Morgan  |  UMBC Department of Information Systems</a:t>
             </a:r>
           </a:p>
+          <a:p>
+            <a:pPr>
+              <a:spcBef>
+                <a:spcPts val="600"/>
+              </a:spcBef>
+            </a:pPr>
+            <a:r>
+              <a:rPr sz="1300" i="1">
+                <a:solidFill>
+                  <a:srgbClr val="1F6F8B"/>
+                </a:solidFill>
+                <a:latin typeface="Calibri"/>
+              </a:rPr>
+              <a:t>Proposed for development and adoption by [Sponsoring Organization], mission sponsor</a:t>
+            </a:r>
+          </a:p>
         </p:txBody>
       </p:sp>
     </p:spTree>
@@ -5060,7 +5289,7 @@
                 </a:solidFill>
                 <a:latin typeface="Calibri"/>
               </a:rPr>
-              <a:t>Measurement: objectives are exogenous and layered</a:t>
+              <a:t>Monitoring answers known questions; observability answers unknown ones</a:t>
             </a:r>
           </a:p>
         </p:txBody>
@@ -5097,8 +5326,8 @@
         </p:nvSpPr>
         <p:spPr>
           <a:xfrm>
-            <a:off x="640080" y="1371600"/>
-            <a:ext cx="11064240" cy="1554480"/>
+            <a:off x="640080" y="1554480"/>
+            <a:ext cx="11064240" cy="4846320"/>
           </a:xfrm>
           <a:prstGeom prst="rect">
             <a:avLst/>
@@ -5117,13 +5346,13 @@
               </a:spcAft>
             </a:pPr>
             <a:r>
-              <a:rPr sz="1700" b="0">
+              <a:rPr sz="1800" b="0">
                 <a:solidFill>
                   <a:srgbClr val="202428"/>
                 </a:solidFill>
                 <a:latin typeface="Calibri"/>
               </a:rPr>
-              <a:t>•  The organization defines its measures, in layers: workflow, division, corporate</a:t>
+              <a:t>•  Monitoring: declared metrics, thresholds, dashboards, chosen in advance</a:t>
             </a:r>
           </a:p>
           <a:p>
@@ -5133,13 +5362,13 @@
               </a:spcAft>
             </a:pPr>
             <a:r>
-              <a:rPr sz="1700" b="0">
+              <a:rPr sz="1800" b="0">
                 <a:solidFill>
                   <a:srgbClr val="202428"/>
                 </a:solidFill>
                 <a:latin typeface="Calibri"/>
               </a:rPr>
-              <a:t>•  The architecture computes them over the record and rolls outcomes up the hierarchy</a:t>
+              <a:t>•  Most current AI tooling is monitoring; it answers questions its designers already hold</a:t>
             </a:r>
           </a:p>
           <a:p>
@@ -5149,41 +5378,33 @@
               </a:spcAft>
             </a:pPr>
             <a:r>
-              <a:rPr sz="1700" b="0">
+              <a:rPr sz="1800" b="0">
                 <a:solidFill>
                   <a:srgbClr val="202428"/>
                 </a:solidFill>
                 <a:latin typeface="Calibri"/>
               </a:rPr>
-              <a:t>•  MOPs, MOEs, KPIs, plus workforce and model acumen and the trust-calibration gap</a:t>
-            </a:r>
-          </a:p>
-        </p:txBody>
-      </p:sp>
-      <p:pic>
-        <p:nvPicPr>
-          <p:cNvPr id="6" name="Picture 5" descr="fig3.png"/>
-          <p:cNvPicPr>
-            <a:picLocks noChangeAspect="1"/>
-          </p:cNvPicPr>
-          <p:nvPr/>
-        </p:nvPicPr>
-        <p:blipFill>
-          <a:blip r:embed="rId2"/>
-          <a:stretch>
-            <a:fillRect/>
-          </a:stretch>
-        </p:blipFill>
-        <p:spPr>
-          <a:xfrm>
-            <a:off x="2759321" y="3063240"/>
-            <a:ext cx="6673053" cy="3429000"/>
-          </a:xfrm>
-          <a:prstGeom prst="rect">
-            <a:avLst/>
-          </a:prstGeom>
-        </p:spPr>
-      </p:pic>
+              <a:t>•  Observability: record behavior at enough fidelity to answer questions not yet formed</a:t>
+            </a:r>
+          </a:p>
+          <a:p>
+            <a:pPr>
+              <a:spcAft>
+                <a:spcPts val="600"/>
+              </a:spcAft>
+            </a:pPr>
+            <a:r>
+              <a:rPr sz="1800" b="0">
+                <a:solidFill>
+                  <a:srgbClr val="202428"/>
+                </a:solidFill>
+                <a:latin typeface="Calibri"/>
+              </a:rPr>
+              <a:t>•  Because AI failure modes emerge, the enterprise needs an observability substrate, not a dashboard</a:t>
+            </a:r>
+          </a:p>
+        </p:txBody>
+      </p:sp>
     </p:spTree>
   </p:cSld>
   <p:clrMapOvr>
@@ -5255,7 +5476,7 @@
                 </a:solidFill>
                 <a:latin typeface="Calibri"/>
               </a:rPr>
-              <a:t>Proving the return on the AI investment</a:t>
+              <a:t>The captured event: immutable and linked</a:t>
             </a:r>
           </a:p>
         </p:txBody>
@@ -5292,8 +5513,8 @@
         </p:nvSpPr>
         <p:spPr>
           <a:xfrm>
-            <a:off x="640080" y="1554480"/>
-            <a:ext cx="11064240" cy="4846320"/>
+            <a:off x="640080" y="1371600"/>
+            <a:ext cx="11064240" cy="1554480"/>
           </a:xfrm>
           <a:prstGeom prst="rect">
             <a:avLst/>
@@ -5312,13 +5533,13 @@
               </a:spcAft>
             </a:pPr>
             <a:r>
-              <a:rPr sz="1800" b="0">
+              <a:rPr sz="1700" b="0">
                 <a:solidFill>
                   <a:srgbClr val="202428"/>
                 </a:solidFill>
                 <a:latin typeface="Calibri"/>
               </a:rPr>
-              <a:t>•  Cost is known from the record; outcome value from the outcome repository</a:t>
+              <a:t>•  Each interaction is one immutable event: the text and the conditions that produced it</a:t>
             </a:r>
           </a:p>
           <a:p>
@@ -5328,13 +5549,13 @@
               </a:spcAft>
             </a:pPr>
             <a:r>
-              <a:rPr sz="1800" b="0">
+              <a:rPr sz="1700" b="0">
                 <a:solidFill>
                   <a:srgbClr val="202428"/>
                 </a:solidFill>
                 <a:latin typeface="Calibri"/>
               </a:rPr>
-              <a:t>•  Return is the relation between them, reported at each layer of the objective hierarchy</a:t>
+              <a:t>•  System prompt, decoding parameters, model version, tool calls, human edits and acceptances</a:t>
             </a:r>
           </a:p>
           <a:p>
@@ -5344,33 +5565,41 @@
               </a:spcAft>
             </a:pPr>
             <a:r>
-              <a:rPr sz="1800" b="0">
+              <a:rPr sz="1700" b="0">
                 <a:solidFill>
                   <a:srgbClr val="202428"/>
                 </a:solidFill>
                 <a:latin typeface="Calibri"/>
               </a:rPr>
-              <a:t>•  'How far does AI multiply human capital' becomes a computed quantity, not an assertion</a:t>
-            </a:r>
-          </a:p>
-          <a:p>
-            <a:pPr lvl="1">
-              <a:spcAft>
-                <a:spcPts val="600"/>
-              </a:spcAft>
-            </a:pPr>
-            <a:r>
-              <a:rPr sz="1600">
-                <a:solidFill>
-                  <a:srgbClr val="5A636B"/>
-                </a:solidFill>
-                <a:latin typeface="Calibri"/>
-              </a:rPr>
-              <a:t>–  The record also shows the downside: over-reliance that degrades workforce competency</a:t>
-            </a:r>
-          </a:p>
-        </p:txBody>
-      </p:sp>
+              <a:t>•  Antecedent and consequent links; a raw append-only form and a queryable structured form</a:t>
+            </a:r>
+          </a:p>
+        </p:txBody>
+      </p:sp>
+      <p:pic>
+        <p:nvPicPr>
+          <p:cNvPr id="6" name="Picture 5" descr="fig2.png"/>
+          <p:cNvPicPr>
+            <a:picLocks noChangeAspect="1"/>
+          </p:cNvPicPr>
+          <p:nvPr/>
+        </p:nvPicPr>
+        <p:blipFill>
+          <a:blip r:embed="rId2"/>
+          <a:stretch>
+            <a:fillRect/>
+          </a:stretch>
+        </p:blipFill>
+        <p:spPr>
+          <a:xfrm>
+            <a:off x="1345581" y="3063240"/>
+            <a:ext cx="9500532" cy="3429000"/>
+          </a:xfrm>
+          <a:prstGeom prst="rect">
+            <a:avLst/>
+          </a:prstGeom>
+        </p:spPr>
+      </p:pic>
     </p:spTree>
   </p:cSld>
   <p:clrMapOvr>
@@ -5442,7 +5671,7 @@
                 </a:solidFill>
                 <a:latin typeface="Calibri"/>
               </a:rPr>
-              <a:t>The hallucination lifecycle, from adverse-event surveillance</a:t>
+              <a:t>Measurement: objectives are exogenous and layered</a:t>
             </a:r>
           </a:p>
         </p:txBody>
@@ -5505,7 +5734,7 @@
                 </a:solidFill>
                 <a:latin typeface="Calibri"/>
               </a:rPr>
-              <a:t>•  Instance, to tracked incidence, to cause and cascade, to mitigation, to prevention</a:t>
+              <a:t>•  The organization defines its measures, in layers: workflow, division, corporate</a:t>
             </a:r>
           </a:p>
           <a:p>
@@ -5521,7 +5750,7 @@
                 </a:solidFill>
                 <a:latin typeface="Calibri"/>
               </a:rPr>
-              <a:t>•  Mitigation efficacy is measured as a change in incidence across a dated boundary</a:t>
+              <a:t>•  The architecture computes them over the record and rolls outcomes up the hierarchy</a:t>
             </a:r>
           </a:p>
           <a:p>
@@ -5537,14 +5766,14 @@
                 </a:solidFill>
                 <a:latin typeface="Calibri"/>
               </a:rPr>
-              <a:t>•  An effective mitigation moved upstream becomes prevention</a:t>
+              <a:t>•  MOPs, MOEs, KPIs, plus workforce and model acumen and the trust-calibration gap</a:t>
             </a:r>
           </a:p>
         </p:txBody>
       </p:sp>
       <p:pic>
         <p:nvPicPr>
-          <p:cNvPr id="6" name="Picture 5" descr="fig4.png"/>
+          <p:cNvPr id="6" name="Picture 5" descr="fig3.png"/>
           <p:cNvPicPr>
             <a:picLocks noChangeAspect="1"/>
           </p:cNvPicPr>
@@ -5558,8 +5787,8 @@
         </p:blipFill>
         <p:spPr>
           <a:xfrm>
-            <a:off x="518007" y="3063240"/>
-            <a:ext cx="11155680" cy="2501904"/>
+            <a:off x="2759321" y="3063240"/>
+            <a:ext cx="6673053" cy="3429000"/>
           </a:xfrm>
           <a:prstGeom prst="rect">
             <a:avLst/>
@@ -5637,7 +5866,7 @@
                 </a:solidFill>
                 <a:latin typeface="Calibri"/>
               </a:rPr>
-              <a:t>A working taxonomy of hallucination</a:t>
+              <a:t>Proving the return on the AI investment</a:t>
             </a:r>
           </a:p>
         </p:txBody>
@@ -5700,7 +5929,7 @@
                 </a:solidFill>
                 <a:latin typeface="Calibri"/>
               </a:rPr>
-              <a:t>•  Fabrication  |  Overconfidence and misrepresentation  |  Staleness</a:t>
+              <a:t>•  Return is the headline output of the metadata repository</a:t>
             </a:r>
           </a:p>
           <a:p>
@@ -5716,7 +5945,7 @@
                 </a:solidFill>
                 <a:latin typeface="Calibri"/>
               </a:rPr>
-              <a:t>•  Context loss  |  Attribution error  |  Scope and instruction divergence</a:t>
+              <a:t>•  Cost is known from the record; outcome value from the outcome repository</a:t>
             </a:r>
           </a:p>
           <a:p>
@@ -5732,7 +5961,7 @@
                 </a:solidFill>
                 <a:latin typeface="Calibri"/>
               </a:rPr>
-              <a:t>•  Agentic and tool-use failure</a:t>
+              <a:t>•  Return is the relation between them, reported at each layer of the objective hierarchy</a:t>
             </a:r>
           </a:p>
           <a:p>
@@ -5748,7 +5977,7 @@
                 </a:solidFill>
                 <a:latin typeface="Calibri"/>
               </a:rPr>
-              <a:t>•  Adjacent, and also tracked: refusal and over-restriction (a withheld benefit), and its inverse</a:t>
+              <a:t>•  'How far does AI multiply human capital' becomes a computed quantity, not an assertion</a:t>
             </a:r>
           </a:p>
           <a:p>
@@ -5764,7 +5993,7 @@
                 </a:solidFill>
                 <a:latin typeface="Calibri"/>
               </a:rPr>
-              <a:t>–  Fabrication is the sharpest: fiction in the form of fact. Provenance keeps it distinguishable.</a:t>
+              <a:t>–  The record also shows the downside: over-reliance that degrades workforce competency</a:t>
             </a:r>
           </a:p>
         </p:txBody>
@@ -5840,7 +6069,7 @@
                 </a:solidFill>
                 <a:latin typeface="Calibri"/>
               </a:rPr>
-              <a:t>Harm forensics: the post-incident investigation</a:t>
+              <a:t>The hallucination lifecycle, from adverse-event surveillance</a:t>
             </a:r>
           </a:p>
         </p:txBody>
@@ -5903,7 +6132,7 @@
                 </a:solidFill>
                 <a:latin typeface="Calibri"/>
               </a:rPr>
-              <a:t>•  When a harm occurs, impact and scope are not optional; they are a required investigation</a:t>
+              <a:t>•  Instance, to tracked incidence, to cause and cascade, to mitigation, to prevention</a:t>
             </a:r>
           </a:p>
           <a:p>
@@ -5919,14 +6148,30 @@
                 </a:solidFill>
                 <a:latin typeface="Calibri"/>
               </a:rPr>
-              <a:t>•  Reconstruct the trigger and conditions, attribute the actors, trace the cascade, prescribe a guardrail</a:t>
+              <a:t>•  Mitigation efficacy is measured as a change in incidence across a dated boundary</a:t>
+            </a:r>
+          </a:p>
+          <a:p>
+            <a:pPr>
+              <a:spcAft>
+                <a:spcPts val="600"/>
+              </a:spcAft>
+            </a:pPr>
+            <a:r>
+              <a:rPr sz="1700" b="0">
+                <a:solidFill>
+                  <a:srgbClr val="202428"/>
+                </a:solidFill>
+                <a:latin typeface="Calibri"/>
+              </a:rPr>
+              <a:t>•  An effective mitigation moved upstream becomes prevention</a:t>
             </a:r>
           </a:p>
         </p:txBody>
       </p:sp>
       <p:pic>
         <p:nvPicPr>
-          <p:cNvPr id="6" name="Picture 5" descr="fig6.png"/>
+          <p:cNvPr id="6" name="Picture 5" descr="fig4.png"/>
           <p:cNvPicPr>
             <a:picLocks noChangeAspect="1"/>
           </p:cNvPicPr>
@@ -5941,7 +6186,7 @@
         <p:spPr>
           <a:xfrm>
             <a:off x="518007" y="3063240"/>
-            <a:ext cx="11155680" cy="2745596"/>
+            <a:ext cx="11155680" cy="2501904"/>
           </a:xfrm>
           <a:prstGeom prst="rect">
             <a:avLst/>
@@ -6019,7 +6264,7 @@
                 </a:solidFill>
                 <a:latin typeface="Calibri"/>
               </a:rPr>
-              <a:t>Attribution: insider misuse vs rogue behavior</a:t>
+              <a:t>A working taxonomy of hallucination</a:t>
             </a:r>
           </a:p>
         </p:txBody>
@@ -6082,7 +6327,7 @@
                 </a:solidFill>
                 <a:latin typeface="Calibri"/>
               </a:rPr>
-              <a:t>•  The record separates human turns and human interactions from model turns and tool calls</a:t>
+              <a:t>•  Fabrication  |  Overconfidence and misrepresentation  |  Staleness</a:t>
             </a:r>
           </a:p>
           <a:p>
@@ -6098,7 +6343,7 @@
                 </a:solidFill>
                 <a:latin typeface="Calibri"/>
               </a:rPr>
-              <a:t>•  AI actor is the source: the model fabricates, misrepresents, or takes an unsafe autonomous action (rogue / agentic)</a:t>
+              <a:t>•  Context loss  |  Attribution error  |  Scope and instruction divergence</a:t>
             </a:r>
           </a:p>
           <a:p>
@@ -6114,7 +6359,7 @@
                 </a:solidFill>
                 <a:latin typeface="Calibri"/>
               </a:rPr>
-              <a:t>•  Human actor is the source: a person directs the AI against the organization (insider misuse; the AI is the instrument)</a:t>
+              <a:t>•  Agentic and tool-use failure</a:t>
             </a:r>
           </a:p>
           <a:p>
@@ -6130,7 +6375,23 @@
                 </a:solidFill>
                 <a:latin typeface="Calibri"/>
               </a:rPr>
-              <a:t>•  Only the record tells them apart: human intent is legible only through the sequence of instructions and uses</a:t>
+              <a:t>•  Adjacent, and also tracked: refusal and over-restriction (a withheld benefit), and its inverse</a:t>
+            </a:r>
+          </a:p>
+          <a:p>
+            <a:pPr lvl="1">
+              <a:spcAft>
+                <a:spcPts val="600"/>
+              </a:spcAft>
+            </a:pPr>
+            <a:r>
+              <a:rPr sz="1600">
+                <a:solidFill>
+                  <a:srgbClr val="5A636B"/>
+                </a:solidFill>
+                <a:latin typeface="Calibri"/>
+              </a:rPr>
+              <a:t>–  Fabrication is the sharpest: fiction in the form of fact. Provenance keeps it distinguishable.</a:t>
             </a:r>
           </a:p>
         </p:txBody>
@@ -6206,7 +6467,7 @@
                 </a:solidFill>
                 <a:latin typeface="Calibri"/>
               </a:rPr>
-              <a:t>From post-mortem to guardrail</a:t>
+              <a:t>Harm forensics: the post-incident investigation</a:t>
             </a:r>
           </a:p>
         </p:txBody>
@@ -6243,8 +6504,8 @@
         </p:nvSpPr>
         <p:spPr>
           <a:xfrm>
-            <a:off x="640080" y="1554480"/>
-            <a:ext cx="11064240" cy="4846320"/>
+            <a:off x="640080" y="1371600"/>
+            <a:ext cx="11064240" cy="1554480"/>
           </a:xfrm>
           <a:prstGeom prst="rect">
             <a:avLst/>
@@ -6263,13 +6524,13 @@
               </a:spcAft>
             </a:pPr>
             <a:r>
-              <a:rPr sz="1800" b="0">
+              <a:rPr sz="1700" b="0">
                 <a:solidFill>
                   <a:srgbClr val="202428"/>
                 </a:solidFill>
                 <a:latin typeface="Calibri"/>
               </a:rPr>
-              <a:t>•  System-prompt engineering: constrain the instruction frame</a:t>
+              <a:t>•  When a harm occurs, impact and scope are not optional; they are a required investigation</a:t>
             </a:r>
           </a:p>
           <a:p>
@@ -6279,97 +6540,41 @@
               </a:spcAft>
             </a:pPr>
             <a:r>
-              <a:rPr sz="1800" b="0">
+              <a:rPr sz="1700" b="0">
                 <a:solidFill>
                   <a:srgbClr val="202428"/>
                 </a:solidFill>
                 <a:latin typeface="Calibri"/>
               </a:rPr>
-              <a:t>•  Input and output validation: check inputs, screen outputs before use</a:t>
-            </a:r>
-          </a:p>
-          <a:p>
-            <a:pPr>
-              <a:spcAft>
-                <a:spcPts val="600"/>
-              </a:spcAft>
-            </a:pPr>
-            <a:r>
-              <a:rPr sz="1800" b="0">
-                <a:solidFill>
-                  <a:srgbClr val="202428"/>
-                </a:solidFill>
-                <a:latin typeface="Calibri"/>
-              </a:rPr>
-              <a:t>•  Human-in-the-loop review gate: require review before an output is used or an action taken</a:t>
-            </a:r>
-          </a:p>
-          <a:p>
-            <a:pPr>
-              <a:spcAft>
-                <a:spcPts val="600"/>
-              </a:spcAft>
-            </a:pPr>
-            <a:r>
-              <a:rPr sz="1800" b="0">
-                <a:solidFill>
-                  <a:srgbClr val="202428"/>
-                </a:solidFill>
-                <a:latin typeface="Calibri"/>
-              </a:rPr>
-              <a:t>•  Tool and permission constraint: limit unauthorized autonomous action</a:t>
-            </a:r>
-          </a:p>
-          <a:p>
-            <a:pPr>
-              <a:spcAft>
-                <a:spcPts val="600"/>
-              </a:spcAft>
-            </a:pPr>
-            <a:r>
-              <a:rPr sz="1800" b="0">
-                <a:solidFill>
-                  <a:srgbClr val="202428"/>
-                </a:solidFill>
-                <a:latin typeface="Calibri"/>
-              </a:rPr>
-              <a:t>•  Workforce hallucination-awareness training: raise the ability to recognize and check failure</a:t>
-            </a:r>
-          </a:p>
-          <a:p>
-            <a:pPr>
-              <a:spcAft>
-                <a:spcPts val="600"/>
-              </a:spcAft>
-            </a:pPr>
-            <a:r>
-              <a:rPr sz="1800" b="0">
-                <a:solidFill>
-                  <a:srgbClr val="202428"/>
-                </a:solidFill>
-                <a:latin typeface="Calibri"/>
-              </a:rPr>
-              <a:t>•  Model version and configuration control</a:t>
-            </a:r>
-          </a:p>
-          <a:p>
-            <a:pPr lvl="1">
-              <a:spcAft>
-                <a:spcPts val="600"/>
-              </a:spcAft>
-            </a:pPr>
-            <a:r>
-              <a:rPr sz="1600">
-                <a:solidFill>
-                  <a:srgbClr val="5A636B"/>
-                </a:solidFill>
-                <a:latin typeface="Calibri"/>
-              </a:rPr>
-              <a:t>–  Each guardrail is dated and its efficacy measured, so a nominal control is distinguishable from a working one</a:t>
-            </a:r>
-          </a:p>
-        </p:txBody>
-      </p:sp>
+              <a:t>•  Reconstruct the trigger and conditions, attribute the actors, trace the cascade, prescribe a guardrail</a:t>
+            </a:r>
+          </a:p>
+        </p:txBody>
+      </p:sp>
+      <p:pic>
+        <p:nvPicPr>
+          <p:cNvPr id="6" name="Picture 5" descr="fig6.png"/>
+          <p:cNvPicPr>
+            <a:picLocks noChangeAspect="1"/>
+          </p:cNvPicPr>
+          <p:nvPr/>
+        </p:nvPicPr>
+        <p:blipFill>
+          <a:blip r:embed="rId2"/>
+          <a:stretch>
+            <a:fillRect/>
+          </a:stretch>
+        </p:blipFill>
+        <p:spPr>
+          <a:xfrm>
+            <a:off x="518007" y="3063240"/>
+            <a:ext cx="11155680" cy="2745596"/>
+          </a:xfrm>
+          <a:prstGeom prst="rect">
+            <a:avLst/>
+          </a:prstGeom>
+        </p:spPr>
+      </p:pic>
     </p:spTree>
   </p:cSld>
   <p:clrMapOvr>
@@ -6441,7 +6646,7 @@
                 </a:solidFill>
                 <a:latin typeface="Calibri"/>
               </a:rPr>
-              <a:t>Obligations and calibrated trust</a:t>
+              <a:t>Attribution: insider misuse vs rogue behavior</a:t>
             </a:r>
           </a:p>
         </p:txBody>
@@ -6504,7 +6709,7 @@
                 </a:solidFill>
                 <a:latin typeface="Calibri"/>
               </a:rPr>
-              <a:t>•  An output can be factually right and still violate a policy, a law, a standard, or a procedure</a:t>
+              <a:t>•  The record separates human turns and human interactions from model turns and tool calls</a:t>
             </a:r>
           </a:p>
           <a:p>
@@ -6520,7 +6725,7 @@
                 </a:solidFill>
                 <a:latin typeface="Calibri"/>
               </a:rPr>
-              <a:t>•  Obligation classes: organizational, legal and regulatory, ethical, procedural, professional, factual, safety</a:t>
+              <a:t>•  AI actor is the source: the model fabricates, misrepresents, or takes an unsafe autonomous action (rogue / agentic)</a:t>
             </a:r>
           </a:p>
           <a:p>
@@ -6536,23 +6741,23 @@
                 </a:solidFill>
                 <a:latin typeface="Calibri"/>
               </a:rPr>
-              <a:t>•  Trust must be calibrated: earned (measured over the record) and curated (surfaced to the user)</a:t>
-            </a:r>
-          </a:p>
-          <a:p>
-            <a:pPr lvl="1">
+              <a:t>•  Human actor is the source: a person directs the AI against the organization (insider misuse; the AI is the instrument)</a:t>
+            </a:r>
+          </a:p>
+          <a:p>
+            <a:pPr>
               <a:spcAft>
                 <a:spcPts val="600"/>
               </a:spcAft>
             </a:pPr>
             <a:r>
-              <a:rPr sz="1600">
-                <a:solidFill>
-                  <a:srgbClr val="5A636B"/>
-                </a:solidFill>
-                <a:latin typeface="Calibri"/>
-              </a:rPr>
-              <a:t>–  Over-trust turns every fabrication into an accepted fact; the record makes over-reliance visible</a:t>
+              <a:rPr sz="1800" b="0">
+                <a:solidFill>
+                  <a:srgbClr val="202428"/>
+                </a:solidFill>
+                <a:latin typeface="Calibri"/>
+              </a:rPr>
+              <a:t>•  Only the record tells them apart: human intent is legible only through the sequence of instructions and uses</a:t>
             </a:r>
           </a:p>
         </p:txBody>
@@ -6628,7 +6833,7 @@
                 </a:solidFill>
                 <a:latin typeface="Calibri"/>
               </a:rPr>
-              <a:t>Deployment, and a future leg</a:t>
+              <a:t>From post-mortem to guardrail</a:t>
             </a:r>
           </a:p>
         </p:txBody>
@@ -6665,8 +6870,8 @@
         </p:nvSpPr>
         <p:spPr>
           <a:xfrm>
-            <a:off x="640080" y="1371600"/>
-            <a:ext cx="11064240" cy="1554480"/>
+            <a:off x="640080" y="1554480"/>
+            <a:ext cx="11064240" cy="4846320"/>
           </a:xfrm>
           <a:prstGeom prst="rect">
             <a:avLst/>
@@ -6685,13 +6890,13 @@
               </a:spcAft>
             </a:pPr>
             <a:r>
-              <a:rPr sz="1700" b="0">
+              <a:rPr sz="1800" b="0">
                 <a:solidFill>
                   <a:srgbClr val="202428"/>
                 </a:solidFill>
                 <a:latin typeface="Calibri"/>
               </a:rPr>
-              <a:t>•  Instrument at the AI-use surfaces: an API gateway or proxy, agent hooks, chat and IDE connectors</a:t>
+              <a:t>•  System-prompt engineering: constrain the instruction frame</a:t>
             </a:r>
           </a:p>
           <a:p>
@@ -6701,13 +6906,13 @@
               </a:spcAft>
             </a:pPr>
             <a:r>
-              <a:rPr sz="1700" b="0">
+              <a:rPr sz="1800" b="0">
                 <a:solidFill>
                   <a:srgbClr val="202428"/>
                 </a:solidFill>
                 <a:latin typeface="Calibri"/>
               </a:rPr>
-              <a:t>•  Converge into one governed store, or isolate systems where separation must be guaranteed</a:t>
+              <a:t>•  Input and output validation: check inputs, screen outputs before use</a:t>
             </a:r>
           </a:p>
           <a:p>
@@ -6717,41 +6922,81 @@
               </a:spcAft>
             </a:pPr>
             <a:r>
-              <a:rPr sz="1700" b="0">
+              <a:rPr sz="1800" b="0">
                 <a:solidFill>
                   <a:srgbClr val="202428"/>
                 </a:solidFill>
                 <a:latin typeface="Calibri"/>
               </a:rPr>
-              <a:t>•  Future: controlled continuity reinjection and per-workflow lane isolation</a:t>
-            </a:r>
-          </a:p>
-        </p:txBody>
-      </p:sp>
-      <p:pic>
-        <p:nvPicPr>
-          <p:cNvPr id="6" name="Picture 5" descr="fig5.png"/>
-          <p:cNvPicPr>
-            <a:picLocks noChangeAspect="1"/>
-          </p:cNvPicPr>
-          <p:nvPr/>
-        </p:nvPicPr>
-        <p:blipFill>
-          <a:blip r:embed="rId2"/>
-          <a:stretch>
-            <a:fillRect/>
-          </a:stretch>
-        </p:blipFill>
-        <p:spPr>
-          <a:xfrm>
-            <a:off x="2019564" y="3063240"/>
-            <a:ext cx="8152567" cy="3429000"/>
-          </a:xfrm>
-          <a:prstGeom prst="rect">
-            <a:avLst/>
-          </a:prstGeom>
-        </p:spPr>
-      </p:pic>
+              <a:t>•  Human-in-the-loop review gate: require review before an output is used or an action taken</a:t>
+            </a:r>
+          </a:p>
+          <a:p>
+            <a:pPr>
+              <a:spcAft>
+                <a:spcPts val="600"/>
+              </a:spcAft>
+            </a:pPr>
+            <a:r>
+              <a:rPr sz="1800" b="0">
+                <a:solidFill>
+                  <a:srgbClr val="202428"/>
+                </a:solidFill>
+                <a:latin typeface="Calibri"/>
+              </a:rPr>
+              <a:t>•  Tool and permission constraint: limit unauthorized autonomous action</a:t>
+            </a:r>
+          </a:p>
+          <a:p>
+            <a:pPr>
+              <a:spcAft>
+                <a:spcPts val="600"/>
+              </a:spcAft>
+            </a:pPr>
+            <a:r>
+              <a:rPr sz="1800" b="0">
+                <a:solidFill>
+                  <a:srgbClr val="202428"/>
+                </a:solidFill>
+                <a:latin typeface="Calibri"/>
+              </a:rPr>
+              <a:t>•  Workforce hallucination-awareness training: raise the ability to recognize and check failure</a:t>
+            </a:r>
+          </a:p>
+          <a:p>
+            <a:pPr>
+              <a:spcAft>
+                <a:spcPts val="600"/>
+              </a:spcAft>
+            </a:pPr>
+            <a:r>
+              <a:rPr sz="1800" b="0">
+                <a:solidFill>
+                  <a:srgbClr val="202428"/>
+                </a:solidFill>
+                <a:latin typeface="Calibri"/>
+              </a:rPr>
+              <a:t>•  Model version and configuration control</a:t>
+            </a:r>
+          </a:p>
+          <a:p>
+            <a:pPr lvl="1">
+              <a:spcAft>
+                <a:spcPts val="600"/>
+              </a:spcAft>
+            </a:pPr>
+            <a:r>
+              <a:rPr sz="1600">
+                <a:solidFill>
+                  <a:srgbClr val="5A636B"/>
+                </a:solidFill>
+                <a:latin typeface="Calibri"/>
+              </a:rPr>
+              <a:t>–  Each guardrail is dated and its efficacy measured, so a nominal control is distinguishable from a working one</a:t>
+            </a:r>
+          </a:p>
+        </p:txBody>
+      </p:sp>
     </p:spTree>
   </p:cSld>
   <p:clrMapOvr>
@@ -6823,7 +7068,7 @@
                 </a:solidFill>
                 <a:latin typeface="Calibri"/>
               </a:rPr>
-              <a:t>Governance, privacy, and compliance</a:t>
+              <a:t>Obligations and calibrated trust</a:t>
             </a:r>
           </a:p>
         </p:txBody>
@@ -6886,7 +7131,7 @@
                 </a:solidFill>
                 <a:latin typeface="Calibri"/>
               </a:rPr>
-              <a:t>•  Segregation by sensitivity is the primary control, not a convenience; it enforces need-to-know</a:t>
+              <a:t>•  An output can be factually right and still violate a policy, a law, a standard, or a procedure</a:t>
             </a:r>
           </a:p>
           <a:p>
@@ -6902,7 +7147,7 @@
                 </a:solidFill>
                 <a:latin typeface="Calibri"/>
               </a:rPr>
-              <a:t>•  Pseudonymous by default: measure roles and workflows, not people; re-identification is a governed, recorded exception</a:t>
+              <a:t>•  Obligation classes: organizational, legal and regulatory, ethical, procedural, professional, factual, safety</a:t>
             </a:r>
           </a:p>
           <a:p>
@@ -6918,23 +7163,23 @@
                 </a:solidFill>
                 <a:latin typeface="Calibri"/>
               </a:rPr>
-              <a:t>•  Insider-threat monitoring is bounded by purpose, by access, and by proportionality</a:t>
-            </a:r>
-          </a:p>
-          <a:p>
-            <a:pPr>
+              <a:t>•  Trust must be calibrated: earned (measured over the record) and curated (surfaced to the user)</a:t>
+            </a:r>
+          </a:p>
+          <a:p>
+            <a:pPr lvl="1">
               <a:spcAft>
                 <a:spcPts val="600"/>
               </a:spcAft>
             </a:pPr>
             <a:r>
-              <a:rPr sz="1800" b="0">
-                <a:solidFill>
-                  <a:srgbClr val="202428"/>
-                </a:solidFill>
-                <a:latin typeface="Calibri"/>
-              </a:rPr>
-              <a:t>•  Supplies the record that NIST AI RMF, ISO 42001 and 23894, the EU AI Act, and OWASP LLM Top 10 presume</a:t>
+              <a:rPr sz="1600">
+                <a:solidFill>
+                  <a:srgbClr val="5A636B"/>
+                </a:solidFill>
+                <a:latin typeface="Calibri"/>
+              </a:rPr>
+              <a:t>–  Over-trust turns every fabrication into an accepted fact; the record makes over-reliance visible</a:t>
             </a:r>
           </a:p>
         </p:txBody>
@@ -7197,7 +7442,7 @@
                 </a:solidFill>
                 <a:latin typeface="Calibri"/>
               </a:rPr>
-              <a:t>Registered predictions: falsifiable, on the record</a:t>
+              <a:t>Deployment, and a future leg</a:t>
             </a:r>
           </a:p>
         </p:txBody>
@@ -7234,8 +7479,8 @@
         </p:nvSpPr>
         <p:spPr>
           <a:xfrm>
-            <a:off x="640080" y="1554480"/>
-            <a:ext cx="11064240" cy="4846320"/>
+            <a:off x="640080" y="1371600"/>
+            <a:ext cx="11064240" cy="1554480"/>
           </a:xfrm>
           <a:prstGeom prst="rect">
             <a:avLst/>
@@ -7254,13 +7499,13 @@
               </a:spcAft>
             </a:pPr>
             <a:r>
-              <a:rPr sz="1800" b="0">
+              <a:rPr sz="1700" b="0">
                 <a:solidFill>
                   <a:srgbClr val="202428"/>
                 </a:solidFill>
                 <a:latin typeface="Calibri"/>
               </a:rPr>
-              <a:t>•  Hallucination recurrence clusters around context-window saturation and compaction, not at random</a:t>
+              <a:t>•  Instrument at the AI-use surfaces: an API gateway or proxy, agent hooks, chat and IDE connectors</a:t>
             </a:r>
           </a:p>
           <a:p>
@@ -7270,13 +7515,13 @@
               </a:spcAft>
             </a:pPr>
             <a:r>
-              <a:rPr sz="1800" b="0">
+              <a:rPr sz="1700" b="0">
                 <a:solidFill>
                   <a:srgbClr val="202428"/>
                 </a:solidFill>
                 <a:latin typeface="Calibri"/>
               </a:rPr>
-              <a:t>•  Newly detectable failure classes rise with the age and size of a broadly captured corpus</a:t>
+              <a:t>•  Converge into one governed store, or isolate systems where separation must be guaranteed</a:t>
             </a:r>
           </a:p>
           <a:p>
@@ -7286,65 +7531,41 @@
               </a:spcAft>
             </a:pPr>
             <a:r>
-              <a:rPr sz="1800" b="0">
+              <a:rPr sz="1700" b="0">
                 <a:solidFill>
                   <a:srgbClr val="202428"/>
                 </a:solidFill>
                 <a:latin typeface="Calibri"/>
               </a:rPr>
-              <a:t>•  Mitigation efficacy is measurable as an incidence change across a dated boundary</a:t>
-            </a:r>
-          </a:p>
-          <a:p>
-            <a:pPr>
-              <a:spcAft>
-                <a:spcPts val="600"/>
-              </a:spcAft>
-            </a:pPr>
-            <a:r>
-              <a:rPr sz="1800" b="0">
-                <a:solidFill>
-                  <a:srgbClr val="202428"/>
-                </a:solidFill>
-                <a:latin typeface="Calibri"/>
-              </a:rPr>
-              <a:t>•  Without the record, an incident's impact is systematically underestimated</a:t>
-            </a:r>
-          </a:p>
-          <a:p>
-            <a:pPr>
-              <a:spcAft>
-                <a:spcPts val="600"/>
-              </a:spcAft>
-            </a:pPr>
-            <a:r>
-              <a:rPr sz="1800" b="0">
-                <a:solidFill>
-                  <a:srgbClr val="202428"/>
-                </a:solidFill>
-                <a:latin typeface="Calibri"/>
-              </a:rPr>
-              <a:t>•  Guardrail efficacy is larger for controls placed upstream of the cause than at the point of harm</a:t>
-            </a:r>
-          </a:p>
-          <a:p>
-            <a:pPr>
-              <a:spcAft>
-                <a:spcPts val="600"/>
-              </a:spcAft>
-            </a:pPr>
-            <a:r>
-              <a:rPr sz="1800" b="0">
-                <a:solidFill>
-                  <a:srgbClr val="202428"/>
-                </a:solidFill>
-                <a:latin typeface="Calibri"/>
-              </a:rPr>
-              <a:t>•  Over-refusal and under-refusal trade off against each other as the instruction frame tightens</a:t>
-            </a:r>
-          </a:p>
-        </p:txBody>
-      </p:sp>
+              <a:t>•  Future: controlled continuity reinjection and per-workflow lane isolation</a:t>
+            </a:r>
+          </a:p>
+        </p:txBody>
+      </p:sp>
+      <p:pic>
+        <p:nvPicPr>
+          <p:cNvPr id="6" name="Picture 5" descr="fig5.png"/>
+          <p:cNvPicPr>
+            <a:picLocks noChangeAspect="1"/>
+          </p:cNvPicPr>
+          <p:nvPr/>
+        </p:nvPicPr>
+        <p:blipFill>
+          <a:blip r:embed="rId2"/>
+          <a:stretch>
+            <a:fillRect/>
+          </a:stretch>
+        </p:blipFill>
+        <p:spPr>
+          <a:xfrm>
+            <a:off x="2019564" y="3063240"/>
+            <a:ext cx="8152567" cy="3429000"/>
+          </a:xfrm>
+          <a:prstGeom prst="rect">
+            <a:avLst/>
+          </a:prstGeom>
+        </p:spPr>
+      </p:pic>
     </p:spTree>
   </p:cSld>
   <p:clrMapOvr>
@@ -7416,6 +7637,615 @@
                 </a:solidFill>
                 <a:latin typeface="Calibri"/>
               </a:rPr>
+              <a:t>Governance, privacy, and compliance</a:t>
+            </a:r>
+          </a:p>
+        </p:txBody>
+      </p:sp>
+      <p:sp>
+        <p:nvSpPr>
+          <p:cNvPr id="4" name="TextBox 3"/>
+          <p:cNvSpPr txBox="1"/>
+          <p:nvPr/>
+        </p:nvSpPr>
+        <p:spPr>
+          <a:xfrm>
+            <a:off x="566928" y="1170432"/>
+            <a:ext cx="2926080" cy="45720"/>
+          </a:xfrm>
+          <a:prstGeom prst="rect">
+            <a:avLst/>
+          </a:prstGeom>
+          <a:noFill/>
+        </p:spPr>
+        <p:txBody>
+          <a:bodyPr wrap="none">
+            <a:spAutoFit/>
+          </a:bodyPr>
+          <a:lstStyle/>
+          <a:p/>
+        </p:txBody>
+      </p:sp>
+      <p:sp>
+        <p:nvSpPr>
+          <p:cNvPr id="5" name="TextBox 4"/>
+          <p:cNvSpPr txBox="1"/>
+          <p:nvPr/>
+        </p:nvSpPr>
+        <p:spPr>
+          <a:xfrm>
+            <a:off x="640080" y="1554480"/>
+            <a:ext cx="11064240" cy="4846320"/>
+          </a:xfrm>
+          <a:prstGeom prst="rect">
+            <a:avLst/>
+          </a:prstGeom>
+          <a:noFill/>
+        </p:spPr>
+        <p:txBody>
+          <a:bodyPr wrap="square">
+            <a:spAutoFit/>
+          </a:bodyPr>
+          <a:lstStyle/>
+          <a:p>
+            <a:pPr>
+              <a:spcAft>
+                <a:spcPts val="600"/>
+              </a:spcAft>
+            </a:pPr>
+            <a:r>
+              <a:rPr sz="1800" b="0">
+                <a:solidFill>
+                  <a:srgbClr val="202428"/>
+                </a:solidFill>
+                <a:latin typeface="Calibri"/>
+              </a:rPr>
+              <a:t>•  Segregation by sensitivity is the primary control, not a convenience; it enforces need-to-know</a:t>
+            </a:r>
+          </a:p>
+          <a:p>
+            <a:pPr>
+              <a:spcAft>
+                <a:spcPts val="600"/>
+              </a:spcAft>
+            </a:pPr>
+            <a:r>
+              <a:rPr sz="1800" b="0">
+                <a:solidFill>
+                  <a:srgbClr val="202428"/>
+                </a:solidFill>
+                <a:latin typeface="Calibri"/>
+              </a:rPr>
+              <a:t>•  Pseudonymous by default: measure roles and workflows, not people; re-identification is a governed, recorded exception</a:t>
+            </a:r>
+          </a:p>
+          <a:p>
+            <a:pPr>
+              <a:spcAft>
+                <a:spcPts val="600"/>
+              </a:spcAft>
+            </a:pPr>
+            <a:r>
+              <a:rPr sz="1800" b="0">
+                <a:solidFill>
+                  <a:srgbClr val="202428"/>
+                </a:solidFill>
+                <a:latin typeface="Calibri"/>
+              </a:rPr>
+              <a:t>•  Insider-threat monitoring is bounded by purpose, by access, and by proportionality</a:t>
+            </a:r>
+          </a:p>
+          <a:p>
+            <a:pPr>
+              <a:spcAft>
+                <a:spcPts val="600"/>
+              </a:spcAft>
+            </a:pPr>
+            <a:r>
+              <a:rPr sz="1800" b="0">
+                <a:solidFill>
+                  <a:srgbClr val="202428"/>
+                </a:solidFill>
+                <a:latin typeface="Calibri"/>
+              </a:rPr>
+              <a:t>•  Supplies the record that NIST AI RMF, ISO 42001 and 23894, the EU AI Act, and OWASP LLM Top 10 presume</a:t>
+            </a:r>
+          </a:p>
+        </p:txBody>
+      </p:sp>
+    </p:spTree>
+  </p:cSld>
+  <p:clrMapOvr>
+    <a:masterClrMapping/>
+  </p:clrMapOvr>
+</p:sld>
+</file>
+
+<file path=ppt/slides/slide22.xml><?xml version="1.0" encoding="utf-8"?>
+<p:sld xmlns:a="http://schemas.openxmlformats.org/drawingml/2006/main" xmlns:p="http://schemas.openxmlformats.org/presentationml/2006/main" xmlns:r="http://schemas.openxmlformats.org/officeDocument/2006/relationships">
+  <p:cSld>
+    <p:spTree>
+      <p:nvGrpSpPr>
+        <p:cNvPr id="1" name=""/>
+        <p:cNvGrpSpPr/>
+        <p:nvPr/>
+      </p:nvGrpSpPr>
+      <p:grpSpPr/>
+      <p:sp>
+        <p:nvSpPr>
+          <p:cNvPr id="2" name="TextBox 1"/>
+          <p:cNvSpPr txBox="1"/>
+          <p:nvPr/>
+        </p:nvSpPr>
+        <p:spPr>
+          <a:xfrm>
+            <a:off x="0" y="0"/>
+            <a:ext cx="201168" cy="6858000"/>
+          </a:xfrm>
+          <a:prstGeom prst="rect">
+            <a:avLst/>
+          </a:prstGeom>
+          <a:noFill/>
+        </p:spPr>
+        <p:txBody>
+          <a:bodyPr wrap="none">
+            <a:spAutoFit/>
+          </a:bodyPr>
+          <a:lstStyle/>
+          <a:p/>
+        </p:txBody>
+      </p:sp>
+      <p:sp>
+        <p:nvSpPr>
+          <p:cNvPr id="3" name="TextBox 2"/>
+          <p:cNvSpPr txBox="1"/>
+          <p:nvPr/>
+        </p:nvSpPr>
+        <p:spPr>
+          <a:xfrm>
+            <a:off x="548640" y="320040"/>
+            <a:ext cx="11064240" cy="914400"/>
+          </a:xfrm>
+          <a:prstGeom prst="rect">
+            <a:avLst/>
+          </a:prstGeom>
+          <a:noFill/>
+        </p:spPr>
+        <p:txBody>
+          <a:bodyPr wrap="square">
+            <a:spAutoFit/>
+          </a:bodyPr>
+          <a:lstStyle/>
+          <a:p>
+            <a:r>
+              <a:rPr sz="3000" b="1">
+                <a:solidFill>
+                  <a:srgbClr val="112A46"/>
+                </a:solidFill>
+                <a:latin typeface="Calibri"/>
+              </a:rPr>
+              <a:t>Registered predictions: falsifiable, on the record</a:t>
+            </a:r>
+          </a:p>
+        </p:txBody>
+      </p:sp>
+      <p:sp>
+        <p:nvSpPr>
+          <p:cNvPr id="4" name="TextBox 3"/>
+          <p:cNvSpPr txBox="1"/>
+          <p:nvPr/>
+        </p:nvSpPr>
+        <p:spPr>
+          <a:xfrm>
+            <a:off x="566928" y="1170432"/>
+            <a:ext cx="2926080" cy="45720"/>
+          </a:xfrm>
+          <a:prstGeom prst="rect">
+            <a:avLst/>
+          </a:prstGeom>
+          <a:noFill/>
+        </p:spPr>
+        <p:txBody>
+          <a:bodyPr wrap="none">
+            <a:spAutoFit/>
+          </a:bodyPr>
+          <a:lstStyle/>
+          <a:p/>
+        </p:txBody>
+      </p:sp>
+      <p:sp>
+        <p:nvSpPr>
+          <p:cNvPr id="5" name="TextBox 4"/>
+          <p:cNvSpPr txBox="1"/>
+          <p:nvPr/>
+        </p:nvSpPr>
+        <p:spPr>
+          <a:xfrm>
+            <a:off x="640080" y="1554480"/>
+            <a:ext cx="11064240" cy="4846320"/>
+          </a:xfrm>
+          <a:prstGeom prst="rect">
+            <a:avLst/>
+          </a:prstGeom>
+          <a:noFill/>
+        </p:spPr>
+        <p:txBody>
+          <a:bodyPr wrap="square">
+            <a:spAutoFit/>
+          </a:bodyPr>
+          <a:lstStyle/>
+          <a:p>
+            <a:pPr>
+              <a:spcAft>
+                <a:spcPts val="600"/>
+              </a:spcAft>
+            </a:pPr>
+            <a:r>
+              <a:rPr sz="1800" b="0">
+                <a:solidFill>
+                  <a:srgbClr val="202428"/>
+                </a:solidFill>
+                <a:latin typeface="Calibri"/>
+              </a:rPr>
+              <a:t>•  Hallucination recurrence clusters around context-window saturation and compaction, not at random</a:t>
+            </a:r>
+          </a:p>
+          <a:p>
+            <a:pPr>
+              <a:spcAft>
+                <a:spcPts val="600"/>
+              </a:spcAft>
+            </a:pPr>
+            <a:r>
+              <a:rPr sz="1800" b="0">
+                <a:solidFill>
+                  <a:srgbClr val="202428"/>
+                </a:solidFill>
+                <a:latin typeface="Calibri"/>
+              </a:rPr>
+              <a:t>•  Newly detectable failure classes rise with the age and size of a broadly captured corpus</a:t>
+            </a:r>
+          </a:p>
+          <a:p>
+            <a:pPr>
+              <a:spcAft>
+                <a:spcPts val="600"/>
+              </a:spcAft>
+            </a:pPr>
+            <a:r>
+              <a:rPr sz="1800" b="0">
+                <a:solidFill>
+                  <a:srgbClr val="202428"/>
+                </a:solidFill>
+                <a:latin typeface="Calibri"/>
+              </a:rPr>
+              <a:t>•  Mitigation efficacy is measurable as an incidence change across a dated boundary</a:t>
+            </a:r>
+          </a:p>
+          <a:p>
+            <a:pPr>
+              <a:spcAft>
+                <a:spcPts val="600"/>
+              </a:spcAft>
+            </a:pPr>
+            <a:r>
+              <a:rPr sz="1800" b="0">
+                <a:solidFill>
+                  <a:srgbClr val="202428"/>
+                </a:solidFill>
+                <a:latin typeface="Calibri"/>
+              </a:rPr>
+              <a:t>•  Without the record, an incident's impact is systematically underestimated</a:t>
+            </a:r>
+          </a:p>
+          <a:p>
+            <a:pPr>
+              <a:spcAft>
+                <a:spcPts val="600"/>
+              </a:spcAft>
+            </a:pPr>
+            <a:r>
+              <a:rPr sz="1800" b="0">
+                <a:solidFill>
+                  <a:srgbClr val="202428"/>
+                </a:solidFill>
+                <a:latin typeface="Calibri"/>
+              </a:rPr>
+              <a:t>•  Guardrail efficacy is larger for controls placed upstream of the cause than at the point of harm</a:t>
+            </a:r>
+          </a:p>
+          <a:p>
+            <a:pPr>
+              <a:spcAft>
+                <a:spcPts val="600"/>
+              </a:spcAft>
+            </a:pPr>
+            <a:r>
+              <a:rPr sz="1800" b="0">
+                <a:solidFill>
+                  <a:srgbClr val="202428"/>
+                </a:solidFill>
+                <a:latin typeface="Calibri"/>
+              </a:rPr>
+              <a:t>•  Over-refusal and under-refusal trade off against each other as the instruction frame tightens</a:t>
+            </a:r>
+          </a:p>
+        </p:txBody>
+      </p:sp>
+    </p:spTree>
+  </p:cSld>
+  <p:clrMapOvr>
+    <a:masterClrMapping/>
+  </p:clrMapOvr>
+</p:sld>
+</file>
+
+<file path=ppt/slides/slide23.xml><?xml version="1.0" encoding="utf-8"?>
+<p:sld xmlns:a="http://schemas.openxmlformats.org/drawingml/2006/main" xmlns:p="http://schemas.openxmlformats.org/presentationml/2006/main" xmlns:r="http://schemas.openxmlformats.org/officeDocument/2006/relationships">
+  <p:cSld>
+    <p:spTree>
+      <p:nvGrpSpPr>
+        <p:cNvPr id="1" name=""/>
+        <p:cNvGrpSpPr/>
+        <p:nvPr/>
+      </p:nvGrpSpPr>
+      <p:grpSpPr/>
+      <p:sp>
+        <p:nvSpPr>
+          <p:cNvPr id="2" name="TextBox 1"/>
+          <p:cNvSpPr txBox="1"/>
+          <p:nvPr/>
+        </p:nvSpPr>
+        <p:spPr>
+          <a:xfrm>
+            <a:off x="0" y="0"/>
+            <a:ext cx="201168" cy="6858000"/>
+          </a:xfrm>
+          <a:prstGeom prst="rect">
+            <a:avLst/>
+          </a:prstGeom>
+          <a:noFill/>
+        </p:spPr>
+        <p:txBody>
+          <a:bodyPr wrap="none">
+            <a:spAutoFit/>
+          </a:bodyPr>
+          <a:lstStyle/>
+          <a:p/>
+        </p:txBody>
+      </p:sp>
+      <p:sp>
+        <p:nvSpPr>
+          <p:cNvPr id="3" name="TextBox 2"/>
+          <p:cNvSpPr txBox="1"/>
+          <p:nvPr/>
+        </p:nvSpPr>
+        <p:spPr>
+          <a:xfrm>
+            <a:off x="548640" y="320040"/>
+            <a:ext cx="11064240" cy="914400"/>
+          </a:xfrm>
+          <a:prstGeom prst="rect">
+            <a:avLst/>
+          </a:prstGeom>
+          <a:noFill/>
+        </p:spPr>
+        <p:txBody>
+          <a:bodyPr wrap="square">
+            <a:spAutoFit/>
+          </a:bodyPr>
+          <a:lstStyle/>
+          <a:p>
+            <a:r>
+              <a:rPr sz="3000" b="1">
+                <a:solidFill>
+                  <a:srgbClr val="112A46"/>
+                </a:solidFill>
+                <a:latin typeface="Calibri"/>
+              </a:rPr>
+              <a:t>Mission sponsor and next steps</a:t>
+            </a:r>
+          </a:p>
+        </p:txBody>
+      </p:sp>
+      <p:sp>
+        <p:nvSpPr>
+          <p:cNvPr id="4" name="TextBox 3"/>
+          <p:cNvSpPr txBox="1"/>
+          <p:nvPr/>
+        </p:nvSpPr>
+        <p:spPr>
+          <a:xfrm>
+            <a:off x="566928" y="1170432"/>
+            <a:ext cx="2926080" cy="45720"/>
+          </a:xfrm>
+          <a:prstGeom prst="rect">
+            <a:avLst/>
+          </a:prstGeom>
+          <a:noFill/>
+        </p:spPr>
+        <p:txBody>
+          <a:bodyPr wrap="none">
+            <a:spAutoFit/>
+          </a:bodyPr>
+          <a:lstStyle/>
+          <a:p/>
+        </p:txBody>
+      </p:sp>
+      <p:sp>
+        <p:nvSpPr>
+          <p:cNvPr id="5" name="TextBox 4"/>
+          <p:cNvSpPr txBox="1"/>
+          <p:nvPr/>
+        </p:nvSpPr>
+        <p:spPr>
+          <a:xfrm>
+            <a:off x="640080" y="1554480"/>
+            <a:ext cx="11064240" cy="4846320"/>
+          </a:xfrm>
+          <a:prstGeom prst="rect">
+            <a:avLst/>
+          </a:prstGeom>
+          <a:noFill/>
+        </p:spPr>
+        <p:txBody>
+          <a:bodyPr wrap="square">
+            <a:spAutoFit/>
+          </a:bodyPr>
+          <a:lstStyle/>
+          <a:p>
+            <a:pPr>
+              <a:spcAft>
+                <a:spcPts val="600"/>
+              </a:spcAft>
+            </a:pPr>
+            <a:r>
+              <a:rPr sz="1800" b="0">
+                <a:solidFill>
+                  <a:srgbClr val="202428"/>
+                </a:solidFill>
+                <a:latin typeface="Calibri"/>
+              </a:rPr>
+              <a:t>•  Proposed for [Sponsoring Organization] as mission sponsor</a:t>
+            </a:r>
+          </a:p>
+          <a:p>
+            <a:pPr>
+              <a:spcAft>
+                <a:spcPts val="600"/>
+              </a:spcAft>
+            </a:pPr>
+            <a:r>
+              <a:rPr sz="1800" b="0">
+                <a:solidFill>
+                  <a:srgbClr val="202428"/>
+                </a:solidFill>
+                <a:latin typeface="Calibri"/>
+              </a:rPr>
+              <a:t>•  Organization data to be provided: AI systems inventory, objective hierarchy, deployment surfaces</a:t>
+            </a:r>
+          </a:p>
+          <a:p>
+            <a:pPr>
+              <a:spcAft>
+                <a:spcPts val="600"/>
+              </a:spcAft>
+            </a:pPr>
+            <a:r>
+              <a:rPr sz="1800" b="0">
+                <a:solidFill>
+                  <a:srgbClr val="202428"/>
+                </a:solidFill>
+                <a:latin typeface="Calibri"/>
+              </a:rPr>
+              <a:t>•  Phased build: content repository first, then metadata derivation, then reporting and ROI</a:t>
+            </a:r>
+          </a:p>
+          <a:p>
+            <a:pPr>
+              <a:spcAft>
+                <a:spcPts val="600"/>
+              </a:spcAft>
+            </a:pPr>
+            <a:r>
+              <a:rPr sz="1800" b="0">
+                <a:solidFill>
+                  <a:srgbClr val="202428"/>
+                </a:solidFill>
+                <a:latin typeface="Calibri"/>
+              </a:rPr>
+              <a:t>•  Pilot on one bounded workflow, measure against its objectives, then widen</a:t>
+            </a:r>
+          </a:p>
+          <a:p>
+            <a:pPr lvl="1">
+              <a:spcAft>
+                <a:spcPts val="600"/>
+              </a:spcAft>
+            </a:pPr>
+            <a:r>
+              <a:rPr sz="1600">
+                <a:solidFill>
+                  <a:srgbClr val="5A636B"/>
+                </a:solidFill>
+                <a:latin typeface="Calibri"/>
+              </a:rPr>
+              <a:t>–  The predictions of the prior slide become the acceptance tests for the pilot</a:t>
+            </a:r>
+          </a:p>
+        </p:txBody>
+      </p:sp>
+    </p:spTree>
+  </p:cSld>
+  <p:clrMapOvr>
+    <a:masterClrMapping/>
+  </p:clrMapOvr>
+</p:sld>
+</file>
+
+<file path=ppt/slides/slide24.xml><?xml version="1.0" encoding="utf-8"?>
+<p:sld xmlns:a="http://schemas.openxmlformats.org/drawingml/2006/main" xmlns:p="http://schemas.openxmlformats.org/presentationml/2006/main" xmlns:r="http://schemas.openxmlformats.org/officeDocument/2006/relationships">
+  <p:cSld>
+    <p:spTree>
+      <p:nvGrpSpPr>
+        <p:cNvPr id="1" name=""/>
+        <p:cNvGrpSpPr/>
+        <p:nvPr/>
+      </p:nvGrpSpPr>
+      <p:grpSpPr/>
+      <p:sp>
+        <p:nvSpPr>
+          <p:cNvPr id="2" name="TextBox 1"/>
+          <p:cNvSpPr txBox="1"/>
+          <p:nvPr/>
+        </p:nvSpPr>
+        <p:spPr>
+          <a:xfrm>
+            <a:off x="0" y="0"/>
+            <a:ext cx="201168" cy="6858000"/>
+          </a:xfrm>
+          <a:prstGeom prst="rect">
+            <a:avLst/>
+          </a:prstGeom>
+          <a:noFill/>
+        </p:spPr>
+        <p:txBody>
+          <a:bodyPr wrap="none">
+            <a:spAutoFit/>
+          </a:bodyPr>
+          <a:lstStyle/>
+          <a:p/>
+        </p:txBody>
+      </p:sp>
+      <p:sp>
+        <p:nvSpPr>
+          <p:cNvPr id="3" name="TextBox 2"/>
+          <p:cNvSpPr txBox="1"/>
+          <p:nvPr/>
+        </p:nvSpPr>
+        <p:spPr>
+          <a:xfrm>
+            <a:off x="548640" y="320040"/>
+            <a:ext cx="11064240" cy="914400"/>
+          </a:xfrm>
+          <a:prstGeom prst="rect">
+            <a:avLst/>
+          </a:prstGeom>
+          <a:noFill/>
+        </p:spPr>
+        <p:txBody>
+          <a:bodyPr wrap="square">
+            <a:spAutoFit/>
+          </a:bodyPr>
+          <a:lstStyle/>
+          <a:p>
+            <a:r>
+              <a:rPr sz="3000" b="1">
+                <a:solidFill>
+                  <a:srgbClr val="112A46"/>
+                </a:solidFill>
+                <a:latin typeface="Calibri"/>
+              </a:rPr>
               <a:t>The ask: build the record first</a:t>
             </a:r>
           </a:p>
@@ -7822,7 +8652,7 @@
                 </a:solidFill>
                 <a:latin typeface="Calibri"/>
               </a:rPr>
-              <a:t>Why the record is indispensable</a:t>
+              <a:t>What we propose: two repositories</a:t>
             </a:r>
           </a:p>
         </p:txBody>
@@ -7859,8 +8689,8 @@
         </p:nvSpPr>
         <p:spPr>
           <a:xfrm>
-            <a:off x="640080" y="1554480"/>
-            <a:ext cx="11064240" cy="4846320"/>
+            <a:off x="640080" y="1371600"/>
+            <a:ext cx="11064240" cy="1554480"/>
           </a:xfrm>
           <a:prstGeom prst="rect">
             <a:avLst/>
@@ -7879,13 +8709,13 @@
               </a:spcAft>
             </a:pPr>
             <a:r>
-              <a:rPr sz="1800" b="0">
+              <a:rPr sz="1700" b="0">
                 <a:solidFill>
                   <a:srgbClr val="202428"/>
                 </a:solidFill>
                 <a:latin typeface="Calibri"/>
               </a:rPr>
-              <a:t>•  AI harms are foreseeable: prompt efficacy is known not to be guaranteed</a:t>
+              <a:t>•  A content repository: the AI session data itself, preserved as the system of record</a:t>
             </a:r>
           </a:p>
           <a:p>
@@ -7895,13 +8725,13 @@
               </a:spcAft>
             </a:pPr>
             <a:r>
-              <a:rPr sz="1800" b="0">
+              <a:rPr sz="1700" b="0">
                 <a:solidFill>
                   <a:srgbClr val="202428"/>
                 </a:solidFill>
                 <a:latin typeface="Calibri"/>
               </a:rPr>
-              <a:t>•  They are detectable: the interaction that carried the fault can be examined</a:t>
+              <a:t>•  A metadata repository: everything derived from that content, to manage the AI and prove its return</a:t>
             </a:r>
           </a:p>
           <a:p>
@@ -7911,49 +8741,41 @@
               </a:spcAft>
             </a:pPr>
             <a:r>
-              <a:rPr sz="1800" b="0">
+              <a:rPr sz="1700" b="0">
                 <a:solidFill>
                   <a:srgbClr val="202428"/>
                 </a:solidFill>
                 <a:latin typeface="Calibri"/>
               </a:rPr>
-              <a:t>•  They are mitigatable: a detected fault can be corrected before it spreads</a:t>
-            </a:r>
-          </a:p>
-          <a:p>
-            <a:pPr>
-              <a:spcAft>
-                <a:spcPts val="600"/>
-              </a:spcAft>
-            </a:pPr>
-            <a:r>
-              <a:rPr sz="1800" b="0">
-                <a:solidFill>
-                  <a:srgbClr val="202428"/>
-                </a:solidFill>
-                <a:latin typeface="Calibri"/>
-              </a:rPr>
-              <a:t>•  A harm you could have foreseen, detected, and mitigated, but did not record, is one you own</a:t>
-            </a:r>
-          </a:p>
-          <a:p>
-            <a:pPr lvl="1">
-              <a:spcAft>
-                <a:spcPts val="600"/>
-              </a:spcAft>
-            </a:pPr>
-            <a:r>
-              <a:rPr sz="1600">
-                <a:solidFill>
-                  <a:srgbClr val="5A636B"/>
-                </a:solidFill>
-                <a:latin typeface="Calibri"/>
-              </a:rPr>
-              <a:t>–  The architecture turns a realized loss into a managed event</a:t>
-            </a:r>
-          </a:p>
-        </p:txBody>
-      </p:sp>
+              <a:t>•  Purpose: give the organization the inventory, utilization, performance, and ROI it needs to manage and justify its AI investment</a:t>
+            </a:r>
+          </a:p>
+        </p:txBody>
+      </p:sp>
+      <p:pic>
+        <p:nvPicPr>
+          <p:cNvPr id="6" name="Picture 5" descr="fig1.png"/>
+          <p:cNvPicPr>
+            <a:picLocks noChangeAspect="1"/>
+          </p:cNvPicPr>
+          <p:nvPr/>
+        </p:nvPicPr>
+        <p:blipFill>
+          <a:blip r:embed="rId2"/>
+          <a:stretch>
+            <a:fillRect/>
+          </a:stretch>
+        </p:blipFill>
+        <p:spPr>
+          <a:xfrm>
+            <a:off x="518007" y="3063240"/>
+            <a:ext cx="11155680" cy="3182474"/>
+          </a:xfrm>
+          <a:prstGeom prst="rect">
+            <a:avLst/>
+          </a:prstGeom>
+        </p:spPr>
+      </p:pic>
     </p:spTree>
   </p:cSld>
   <p:clrMapOvr>
@@ -8025,7 +8847,7 @@
                 </a:solidFill>
                 <a:latin typeface="Calibri"/>
               </a:rPr>
-              <a:t>Three cases that make it concrete</a:t>
+              <a:t>The metadata repository: what the investment bought</a:t>
             </a:r>
           </a:p>
         </p:txBody>
@@ -8088,7 +8910,55 @@
                 </a:solidFill>
                 <a:latin typeface="Calibri"/>
               </a:rPr>
-              <a:t>•  A prompt that quietly stops working</a:t>
+              <a:t>•  Inventory: which AI systems, models, and versions are deployed, and by whom</a:t>
+            </a:r>
+          </a:p>
+          <a:p>
+            <a:pPr>
+              <a:spcAft>
+                <a:spcPts val="600"/>
+              </a:spcAft>
+            </a:pPr>
+            <a:r>
+              <a:rPr sz="1800" b="0">
+                <a:solidFill>
+                  <a:srgbClr val="202428"/>
+                </a:solidFill>
+                <a:latin typeface="Calibri"/>
+              </a:rPr>
+              <a:t>•  Utilization: sessions, tokens, and spend, across teams and workflows</a:t>
+            </a:r>
+          </a:p>
+          <a:p>
+            <a:pPr>
+              <a:spcAft>
+                <a:spcPts val="600"/>
+              </a:spcAft>
+            </a:pPr>
+            <a:r>
+              <a:rPr sz="1800" b="0">
+                <a:solidFill>
+                  <a:srgbClr val="202428"/>
+                </a:solidFill>
+                <a:latin typeface="Calibri"/>
+              </a:rPr>
+              <a:t>•  Performance and effectiveness: task success, rework, acceptance, escalation</a:t>
+            </a:r>
+          </a:p>
+          <a:p>
+            <a:pPr>
+              <a:spcAft>
+                <a:spcPts val="600"/>
+              </a:spcAft>
+            </a:pPr>
+            <a:r>
+              <a:rPr sz="1800" b="0">
+                <a:solidFill>
+                  <a:srgbClr val="202428"/>
+                </a:solidFill>
+                <a:latin typeface="Calibri"/>
+              </a:rPr>
+              <a:t>•  Return on investment: cost from the record set against attributable outcome value, per objective layer</a:t>
             </a:r>
           </a:p>
           <a:p>
@@ -8104,71 +8974,7 @@
                 </a:solidFill>
                 <a:latin typeface="Calibri"/>
               </a:rPr>
-              <a:t>–  A customer's phrasing pushes the model outside its system prompt; it states a policy we do not hold. With the record, the deviation is caught before it recurs.</a:t>
-            </a:r>
-          </a:p>
-          <a:p>
-            <a:pPr>
-              <a:spcAft>
-                <a:spcPts val="600"/>
-              </a:spcAft>
-            </a:pPr>
-            <a:r>
-              <a:rPr sz="1800" b="0">
-                <a:solidFill>
-                  <a:srgbClr val="202428"/>
-                </a:solidFill>
-                <a:latin typeface="Calibri"/>
-              </a:rPr>
-              <a:t>•  A fabrication that enters the record as fact</a:t>
-            </a:r>
-          </a:p>
-          <a:p>
-            <a:pPr lvl="1">
-              <a:spcAft>
-                <a:spcPts val="600"/>
-              </a:spcAft>
-            </a:pPr>
-            <a:r>
-              <a:rPr sz="1600">
-                <a:solidFill>
-                  <a:srgbClr val="5A636B"/>
-                </a:solidFill>
-                <a:latin typeface="Calibri"/>
-              </a:rPr>
-              <a:t>–  A model adds a figure the source does not contain; it moves into a report, then a decision. With provenance, it is traceable and the correction reaches everywhere it went.</a:t>
-            </a:r>
-          </a:p>
-          <a:p>
-            <a:pPr>
-              <a:spcAft>
-                <a:spcPts val="600"/>
-              </a:spcAft>
-            </a:pPr>
-            <a:r>
-              <a:rPr sz="1800" b="0">
-                <a:solidFill>
-                  <a:srgbClr val="202428"/>
-                </a:solidFill>
-                <a:latin typeface="Calibri"/>
-              </a:rPr>
-              <a:t>•  A cascade across a long session</a:t>
-            </a:r>
-          </a:p>
-          <a:p>
-            <a:pPr lvl="1">
-              <a:spcAft>
-                <a:spcPts val="600"/>
-              </a:spcAft>
-            </a:pPr>
-            <a:r>
-              <a:rPr sz="1600">
-                <a:solidFill>
-                  <a:srgbClr val="5A636B"/>
-                </a:solidFill>
-                <a:latin typeface="Calibri"/>
-              </a:rPr>
-              <a:t>–  The model forgets an earlier constraint; later outputs violate it while each looks locally fine. With session capture, the drift is flagged before the output is trusted.</a:t>
+              <a:t>–  Segregated by sensitivity: risk and continuity metadata governed on their own terms</a:t>
             </a:r>
           </a:p>
         </p:txBody>
@@ -8244,7 +9050,7 @@
                 </a:solidFill>
                 <a:latin typeface="Calibri"/>
               </a:rPr>
-              <a:t>Capture before the question</a:t>
+              <a:t>The content repository: the system of record</a:t>
             </a:r>
           </a:p>
         </p:txBody>
@@ -8307,7 +9113,7 @@
                 </a:solidFill>
                 <a:latin typeface="Calibri"/>
               </a:rPr>
-              <a:t>•  Visibility is a precondition, not a feature: you cannot measure what you did not record</a:t>
+              <a:t>•  Holds the session data itself: system and user prompts, model turns, tool calls, context</a:t>
             </a:r>
           </a:p>
           <a:p>
@@ -8323,7 +9129,7 @@
                 </a:solidFill>
                 <a:latin typeface="Calibri"/>
               </a:rPr>
-              <a:t>•  The behaviors worth measuring are not known when the data is captured</a:t>
+              <a:t>•  Each interaction is one immutable event, stored with the conditions that produced it</a:t>
             </a:r>
           </a:p>
           <a:p>
@@ -8339,7 +9145,7 @@
                 </a:solidFill>
                 <a:latin typeface="Calibri"/>
               </a:rPr>
-              <a:t>•  A new failure mode becomes legible only after instances accumulate and someone builds the lens</a:t>
+              <a:t>•  Linked antecedents and consequents; a raw append-only form and a queryable form</a:t>
             </a:r>
           </a:p>
           <a:p>
@@ -8355,23 +9161,7 @@
                 </a:solidFill>
                 <a:latin typeface="Calibri"/>
               </a:rPr>
-              <a:t>•  Omitted capture is unrecoverable: a gap is a permanent blind spot, not a delay</a:t>
-            </a:r>
-          </a:p>
-          <a:p>
-            <a:pPr lvl="1">
-              <a:spcAft>
-                <a:spcPts val="600"/>
-              </a:spcAft>
-            </a:pPr>
-            <a:r>
-              <a:rPr sz="1600">
-                <a:solidFill>
-                  <a:srgbClr val="5A636B"/>
-                </a:solidFill>
-                <a:latin typeface="Calibri"/>
-              </a:rPr>
-              <a:t>–  Capturing now is cheap; reconstructing later is impossible</a:t>
+              <a:t>•  It is the source every metadata measure, every risk detection, and every forensic query draws from</a:t>
             </a:r>
           </a:p>
         </p:txBody>
@@ -8447,7 +9237,7 @@
                 </a:solidFill>
                 <a:latin typeface="Calibri"/>
               </a:rPr>
-              <a:t>Monitoring answers known questions; observability answers unknown ones</a:t>
+              <a:t>Why the record is indispensable</a:t>
             </a:r>
           </a:p>
         </p:txBody>
@@ -8510,7 +9300,7 @@
                 </a:solidFill>
                 <a:latin typeface="Calibri"/>
               </a:rPr>
-              <a:t>•  Monitoring: declared metrics, thresholds, dashboards, chosen in advance</a:t>
+              <a:t>•  AI harms are foreseeable: prompt efficacy is known not to be guaranteed</a:t>
             </a:r>
           </a:p>
           <a:p>
@@ -8526,7 +9316,7 @@
                 </a:solidFill>
                 <a:latin typeface="Calibri"/>
               </a:rPr>
-              <a:t>•  Most current AI tooling is monitoring; it answers questions its designers already hold</a:t>
+              <a:t>•  They are detectable: the interaction that carried the fault can be examined</a:t>
             </a:r>
           </a:p>
           <a:p>
@@ -8542,7 +9332,7 @@
                 </a:solidFill>
                 <a:latin typeface="Calibri"/>
               </a:rPr>
-              <a:t>•  Observability: record behavior at enough fidelity to answer questions not yet formed</a:t>
+              <a:t>•  They are mitigatable: a detected fault can be corrected before it spreads</a:t>
             </a:r>
           </a:p>
           <a:p>
@@ -8558,7 +9348,23 @@
                 </a:solidFill>
                 <a:latin typeface="Calibri"/>
               </a:rPr>
-              <a:t>•  Because AI failure modes emerge, the enterprise needs an observability substrate, not a dashboard</a:t>
+              <a:t>•  A harm you could have foreseen, detected, and mitigated, but did not record, is one you own</a:t>
+            </a:r>
+          </a:p>
+          <a:p>
+            <a:pPr lvl="1">
+              <a:spcAft>
+                <a:spcPts val="600"/>
+              </a:spcAft>
+            </a:pPr>
+            <a:r>
+              <a:rPr sz="1600">
+                <a:solidFill>
+                  <a:srgbClr val="5A636B"/>
+                </a:solidFill>
+                <a:latin typeface="Calibri"/>
+              </a:rPr>
+              <a:t>–  The architecture turns a realized loss into a managed event</a:t>
             </a:r>
           </a:p>
         </p:txBody>
@@ -8634,7 +9440,7 @@
                 </a:solidFill>
                 <a:latin typeface="Calibri"/>
               </a:rPr>
-              <a:t>Reference architecture: a simple flow</a:t>
+              <a:t>Three cases that make it concrete</a:t>
             </a:r>
           </a:p>
         </p:txBody>
@@ -8671,8 +9477,8 @@
         </p:nvSpPr>
         <p:spPr>
           <a:xfrm>
-            <a:off x="640080" y="1371600"/>
-            <a:ext cx="11064240" cy="1554480"/>
+            <a:off x="640080" y="1554480"/>
+            <a:ext cx="11064240" cy="4846320"/>
           </a:xfrm>
           <a:prstGeom prst="rect">
             <a:avLst/>
@@ -8691,13 +9497,29 @@
               </a:spcAft>
             </a:pPr>
             <a:r>
-              <a:rPr sz="1700" b="0">
+              <a:rPr sz="1800" b="0">
                 <a:solidFill>
                   <a:srgbClr val="202428"/>
                 </a:solidFill>
                 <a:latin typeface="Calibri"/>
               </a:rPr>
-              <a:t>•  Instrument the AI systems in use; store their session content</a:t>
+              <a:t>•  A prompt that quietly stops working</a:t>
+            </a:r>
+          </a:p>
+          <a:p>
+            <a:pPr lvl="1">
+              <a:spcAft>
+                <a:spcPts val="600"/>
+              </a:spcAft>
+            </a:pPr>
+            <a:r>
+              <a:rPr sz="1600">
+                <a:solidFill>
+                  <a:srgbClr val="5A636B"/>
+                </a:solidFill>
+                <a:latin typeface="Calibri"/>
+              </a:rPr>
+              <a:t>–  A customer's phrasing pushes the model outside its system prompt; it states a policy we do not hold. With the record, the deviation is caught before it recurs.</a:t>
             </a:r>
           </a:p>
           <a:p>
@@ -8707,41 +9529,65 @@
               </a:spcAft>
             </a:pPr>
             <a:r>
-              <a:rPr sz="1700" b="0">
+              <a:rPr sz="1800" b="0">
                 <a:solidFill>
                   <a:srgbClr val="202428"/>
                 </a:solidFill>
                 <a:latin typeface="Calibri"/>
               </a:rPr>
-              <a:t>•  Derive metadata into stores separated by sensitivity; draw outcomes and risks; report</a:t>
-            </a:r>
-          </a:p>
-        </p:txBody>
-      </p:sp>
-      <p:pic>
-        <p:nvPicPr>
-          <p:cNvPr id="6" name="Picture 5" descr="fig1.png"/>
-          <p:cNvPicPr>
-            <a:picLocks noChangeAspect="1"/>
-          </p:cNvPicPr>
-          <p:nvPr/>
-        </p:nvPicPr>
-        <p:blipFill>
-          <a:blip r:embed="rId2"/>
-          <a:stretch>
-            <a:fillRect/>
-          </a:stretch>
-        </p:blipFill>
-        <p:spPr>
-          <a:xfrm>
-            <a:off x="518007" y="3063240"/>
-            <a:ext cx="11155680" cy="3287537"/>
-          </a:xfrm>
-          <a:prstGeom prst="rect">
-            <a:avLst/>
-          </a:prstGeom>
-        </p:spPr>
-      </p:pic>
+              <a:t>•  A fabrication that enters the record as fact</a:t>
+            </a:r>
+          </a:p>
+          <a:p>
+            <a:pPr lvl="1">
+              <a:spcAft>
+                <a:spcPts val="600"/>
+              </a:spcAft>
+            </a:pPr>
+            <a:r>
+              <a:rPr sz="1600">
+                <a:solidFill>
+                  <a:srgbClr val="5A636B"/>
+                </a:solidFill>
+                <a:latin typeface="Calibri"/>
+              </a:rPr>
+              <a:t>–  A model adds a figure the source does not contain; it moves into a report, then a decision. With provenance, it is traceable and the correction reaches everywhere it went.</a:t>
+            </a:r>
+          </a:p>
+          <a:p>
+            <a:pPr>
+              <a:spcAft>
+                <a:spcPts val="600"/>
+              </a:spcAft>
+            </a:pPr>
+            <a:r>
+              <a:rPr sz="1800" b="0">
+                <a:solidFill>
+                  <a:srgbClr val="202428"/>
+                </a:solidFill>
+                <a:latin typeface="Calibri"/>
+              </a:rPr>
+              <a:t>•  A cascade across a long session</a:t>
+            </a:r>
+          </a:p>
+          <a:p>
+            <a:pPr lvl="1">
+              <a:spcAft>
+                <a:spcPts val="600"/>
+              </a:spcAft>
+            </a:pPr>
+            <a:r>
+              <a:rPr sz="1600">
+                <a:solidFill>
+                  <a:srgbClr val="5A636B"/>
+                </a:solidFill>
+                <a:latin typeface="Calibri"/>
+              </a:rPr>
+              <a:t>–  The model forgets an earlier constraint; later outputs violate it while each looks locally fine. With session capture, the drift is flagged before the output is trusted.</a:t>
+            </a:r>
+          </a:p>
+        </p:txBody>
+      </p:sp>
     </p:spTree>
   </p:cSld>
   <p:clrMapOvr>
@@ -8813,7 +9659,7 @@
                 </a:solidFill>
                 <a:latin typeface="Calibri"/>
               </a:rPr>
-              <a:t>The captured event: immutable and linked</a:t>
+              <a:t>Capture before the question</a:t>
             </a:r>
           </a:p>
         </p:txBody>
@@ -8850,8 +9696,8 @@
         </p:nvSpPr>
         <p:spPr>
           <a:xfrm>
-            <a:off x="640080" y="1371600"/>
-            <a:ext cx="11064240" cy="1554480"/>
+            <a:off x="640080" y="1554480"/>
+            <a:ext cx="11064240" cy="4846320"/>
           </a:xfrm>
           <a:prstGeom prst="rect">
             <a:avLst/>
@@ -8870,13 +9716,13 @@
               </a:spcAft>
             </a:pPr>
             <a:r>
-              <a:rPr sz="1700" b="0">
+              <a:rPr sz="1800" b="0">
                 <a:solidFill>
                   <a:srgbClr val="202428"/>
                 </a:solidFill>
                 <a:latin typeface="Calibri"/>
               </a:rPr>
-              <a:t>•  Each interaction is one immutable event: the text and the conditions that produced it</a:t>
+              <a:t>•  Visibility is a precondition, not a feature: you cannot measure what you did not record</a:t>
             </a:r>
           </a:p>
           <a:p>
@@ -8886,13 +9732,13 @@
               </a:spcAft>
             </a:pPr>
             <a:r>
-              <a:rPr sz="1700" b="0">
+              <a:rPr sz="1800" b="0">
                 <a:solidFill>
                   <a:srgbClr val="202428"/>
                 </a:solidFill>
                 <a:latin typeface="Calibri"/>
               </a:rPr>
-              <a:t>•  System prompt, decoding parameters, model version, tool calls, human edits and acceptances</a:t>
+              <a:t>•  The behaviors worth measuring are not known when the data is captured</a:t>
             </a:r>
           </a:p>
           <a:p>
@@ -8902,41 +9748,49 @@
               </a:spcAft>
             </a:pPr>
             <a:r>
-              <a:rPr sz="1700" b="0">
+              <a:rPr sz="1800" b="0">
                 <a:solidFill>
                   <a:srgbClr val="202428"/>
                 </a:solidFill>
                 <a:latin typeface="Calibri"/>
               </a:rPr>
-              <a:t>•  Antecedent and consequent links; a raw append-only form and a queryable structured form</a:t>
-            </a:r>
-          </a:p>
-        </p:txBody>
-      </p:sp>
-      <p:pic>
-        <p:nvPicPr>
-          <p:cNvPr id="6" name="Picture 5" descr="fig2.png"/>
-          <p:cNvPicPr>
-            <a:picLocks noChangeAspect="1"/>
-          </p:cNvPicPr>
-          <p:nvPr/>
-        </p:nvPicPr>
-        <p:blipFill>
-          <a:blip r:embed="rId2"/>
-          <a:stretch>
-            <a:fillRect/>
-          </a:stretch>
-        </p:blipFill>
-        <p:spPr>
-          <a:xfrm>
-            <a:off x="1345581" y="3063240"/>
-            <a:ext cx="9500532" cy="3429000"/>
-          </a:xfrm>
-          <a:prstGeom prst="rect">
-            <a:avLst/>
-          </a:prstGeom>
-        </p:spPr>
-      </p:pic>
+              <a:t>•  A new failure mode becomes legible only after instances accumulate and someone builds the lens</a:t>
+            </a:r>
+          </a:p>
+          <a:p>
+            <a:pPr>
+              <a:spcAft>
+                <a:spcPts val="600"/>
+              </a:spcAft>
+            </a:pPr>
+            <a:r>
+              <a:rPr sz="1800" b="0">
+                <a:solidFill>
+                  <a:srgbClr val="202428"/>
+                </a:solidFill>
+                <a:latin typeface="Calibri"/>
+              </a:rPr>
+              <a:t>•  Omitted capture is unrecoverable: a gap is a permanent blind spot, not a delay</a:t>
+            </a:r>
+          </a:p>
+          <a:p>
+            <a:pPr lvl="1">
+              <a:spcAft>
+                <a:spcPts val="600"/>
+              </a:spcAft>
+            </a:pPr>
+            <a:r>
+              <a:rPr sz="1600">
+                <a:solidFill>
+                  <a:srgbClr val="5A636B"/>
+                </a:solidFill>
+                <a:latin typeface="Calibri"/>
+              </a:rPr>
+              <a:t>–  Capturing now is cheap; reconstructing later is impossible</a:t>
+            </a:r>
+          </a:p>
+        </p:txBody>
+      </p:sp>
     </p:spTree>
   </p:cSld>
   <p:clrMapOvr>

</xml_diff>

<commit_message>
Deck: add scale, split metadata (quantitative) vs content (qualitative/forensic)
- Problem slide names the scale: dozens of purpose-based systems, tens of thousands of users
- Proposal slide states the division of labor; Fig 1 updated to match
- Metadata slide broadened: UX/journey, market segmentation, token consumption, GPU/network utilization, user base, scale/scope
- New content-repository slide: forensics, hallucination study, qualitative performance and work-product measures
- 10 main slides + 4 backups

Co-Authored-By: Claude Opus 4.8 <noreply@anthropic.com>
</commit_message>
<xml_diff>
--- a/papers/ai-metadata-session-data-repository/AI_Metadata_Repository_Briefing.pptx
+++ b/papers/ai-metadata-session-data-repository/AI_Metadata_Repository_Briefing.pptx
@@ -19,6 +19,7 @@
     <p:sldId id="267" r:id="rId19"/>
     <p:sldId id="268" r:id="rId20"/>
     <p:sldId id="269" r:id="rId21"/>
+    <p:sldId id="270" r:id="rId22"/>
   </p:sldIdLst>
   <p:sldSz cx="12191695" cy="6858000" type="screen4x3"/>
   <p:notesSz cx="6858000" cy="9144000"/>
@@ -585,7 +586,7 @@
           <a:lstStyle/>
           <a:p>
             <a:r>
-              <a:t>Backup slides for likely questions: how capture works, how ROI is computed, the hallucination detail, and the falsifiable predictions.</a:t>
+              <a:t>To close, back to the one sentence. An organization cannot manage what it cannot see, and it cannot see its use of AI without a record of that use. Build the two repositories that hold that record and two things become true at once: the harms of AI become foreseeable, detectable, and mitigatable, and the value of AI, including how far it multiplies our people's output, becomes calculable. The same record serves both, so an organization that keeps it can both defend against AI liability and prove its return, and one that does not can do neither. The one property I want to leave you with is that this is time-sensitive: capture we do not start today is capture we can never recover. The ask is simple, and it is to sponsor building the record first.</a:t>
             </a:r>
           </a:p>
         </p:txBody>
@@ -655,7 +656,7 @@
           <a:lstStyle/>
           <a:p>
             <a:r>
-              <a:t>How capture actually works. Each interaction is stored as one immutable event that records the exchanged text and the conditions that produced it: the system prompt, the decoding parameters, the model version, the tool calls, and the human interactions, the edits, acceptances, and rejections. A hallucination produced under a permissive prompt is a different event, with a different cause, from the same words under a constraining one. Events link to their antecedents and consequents, so a cascade is traversed rather than guessed, and each is kept twice: a raw append-only form that is never rewritten, and a structured, queryable form. A later re-classification adds a label; it never alters the original. This is the content repository, and every downstream number and detection is a query over it.</a:t>
+              <a:t>Backup slides for likely questions: how capture works, how ROI is computed, the hallucination detail, and the falsifiable predictions.</a:t>
             </a:r>
           </a:p>
         </p:txBody>
@@ -725,7 +726,7 @@
           <a:lstStyle/>
           <a:p>
             <a:r>
-              <a:t>How the metadata repository produces its numbers. Measures are not properties of the architecture; they are the organization's objectives, defined in layers, corporate at the top, division and workflow below, each naming its own measures. The architecture does not impose a fixed metric set; it collects, detects, catalogs, and stores the outcomes those measures are computed from and rolls them up. Measures of performance sit close to the interaction, latency, availability, token cost; measures of effectiveness against the objective a workflow serves, task success, rework, escalation; KPIs are the business-facing roll-ups. On top it adds measures a fixed dashboard misses: workforce acumen, model drift, and the gap between how much people trust the model and how reliable it is. Return is cost from the record set against attributable outcome value, per layer.</a:t>
+              <a:t>How capture actually works. Each interaction is stored as one immutable event that records the exchanged text and the conditions that produced it: the system prompt, the decoding parameters, the model version, the tool calls, and the human interactions, the edits, acceptances, and rejections. A hallucination produced under a permissive prompt is a different event, with a different cause, from the same words under a constraining one. Events link to their antecedents and consequents, so a cascade is traversed rather than guessed, and each is kept twice: a raw append-only form that is never rewritten, and a structured, queryable form. A later re-classification adds a label; it never alters the original. This is the content repository, and every downstream number and detection is a query over it.</a:t>
             </a:r>
           </a:p>
         </p:txBody>
@@ -795,7 +796,7 @@
           <a:lstStyle/>
           <a:p>
             <a:r>
-              <a:t>The hallucination detail. We borrow the shape from adverse-event surveillance. A single failure is an instance, and its importance is not evident at the moment it occurs, because impact is a function of trajectory. Repeated instances form an incidence we track. Some trace to a cause; some cascade. A mitigation applied after detection has an efficacy measured as a change in incidence across the dated boundary where we applied it, and a mitigation moved upstream becomes prevention. The taxonomy names the forms so detection knows what to look for: fabrication, overconfidence and misrepresentation, staleness, context loss, attribution error, scope and instruction divergence, and agentic or tool-use failure. Refusal, over- and under-restriction, is tracked alongside as an adjacent mode. Fabrication is the sharpest, and provenance is the defense: it keeps a generated assertion distinguishable from an established fact.</a:t>
+              <a:t>How the metadata repository produces its numbers. Measures are not properties of the architecture; they are the organization's objectives, defined in layers, corporate at the top, division and workflow below, each naming its own measures. The architecture does not impose a fixed metric set; it collects, detects, catalogs, and stores the outcomes those measures are computed from and rolls them up. Measures of performance sit close to the interaction, latency, availability, token cost; measures of effectiveness against the objective a workflow serves, task success, rework, escalation; KPIs are the business-facing roll-ups. On top it adds measures a fixed dashboard misses: workforce acumen, model drift, and the gap between how much people trust the model and how reliable it is. Return is cost from the record set against attributable outcome value, per layer.</a:t>
             </a:r>
           </a:p>
         </p:txBody>
@@ -865,6 +866,76 @@
           <a:lstStyle/>
           <a:p>
             <a:r>
+              <a:t>The hallucination detail. We borrow the shape from adverse-event surveillance. A single failure is an instance, and its importance is not evident at the moment it occurs, because impact is a function of trajectory. Repeated instances form an incidence we track. Some trace to a cause; some cascade. A mitigation applied after detection has an efficacy measured as a change in incidence across the dated boundary where we applied it, and a mitigation moved upstream becomes prevention. The taxonomy names the forms so detection knows what to look for: fabrication, overconfidence and misrepresentation, staleness, context loss, attribution error, scope and instruction divergence, and agentic or tool-use failure. Refusal, over- and under-restriction, is tracked alongside as an adjacent mode. Fabrication is the sharpest, and provenance is the defense: it keeps a generated assertion distinguishable from an established fact.</a:t>
+            </a:r>
+          </a:p>
+        </p:txBody>
+      </p:sp>
+      <p:sp>
+        <p:nvSpPr>
+          <p:cNvPr id="4" name="Slide Number Placeholder 3"/>
+          <p:cNvSpPr>
+            <a:spLocks noGrp="1"/>
+          </p:cNvSpPr>
+          <p:nvPr>
+            <p:ph type="sldNum" idx="5" sz="quarter"/>
+          </p:nvPr>
+        </p:nvSpPr>
+        <p:spPr/>
+      </p:sp>
+    </p:spTree>
+  </p:cSld>
+  <p:clrMapOvr>
+    <a:masterClrMapping/>
+  </p:clrMapOvr>
+</p:notes>
+</file>
+
+<file path=ppt/notesSlides/notesSlide15.xml><?xml version="1.0" encoding="utf-8"?>
+<p:notes xmlns:a="http://schemas.openxmlformats.org/drawingml/2006/main" xmlns:p="http://schemas.openxmlformats.org/presentationml/2006/main" xmlns:r="http://schemas.openxmlformats.org/officeDocument/2006/relationships">
+  <p:cSld>
+    <p:spTree>
+      <p:nvGrpSpPr>
+        <p:cNvPr id="1" name=""/>
+        <p:cNvGrpSpPr/>
+        <p:nvPr/>
+      </p:nvGrpSpPr>
+      <p:grpSpPr>
+        <a:xfrm>
+          <a:off x="0" y="0"/>
+          <a:ext cx="0" cy="0"/>
+          <a:chOff x="0" y="0"/>
+          <a:chExt cx="0" cy="0"/>
+        </a:xfrm>
+      </p:grpSpPr>
+      <p:sp>
+        <p:nvSpPr>
+          <p:cNvPr id="2" name="Slide Image Placeholder 1"/>
+          <p:cNvSpPr>
+            <a:spLocks noGrp="1"/>
+          </p:cNvSpPr>
+          <p:nvPr>
+            <p:ph type="sldImg" idx="2"/>
+          </p:nvPr>
+        </p:nvSpPr>
+        <p:spPr/>
+      </p:sp>
+      <p:sp>
+        <p:nvSpPr>
+          <p:cNvPr id="3" name="Notes Placeholder 2"/>
+          <p:cNvSpPr>
+            <a:spLocks noGrp="1"/>
+          </p:cNvSpPr>
+          <p:nvPr>
+            <p:ph type="body" idx="3" sz="quarter"/>
+          </p:nvPr>
+        </p:nvSpPr>
+        <p:spPr/>
+        <p:txBody>
+          <a:bodyPr/>
+          <a:lstStyle/>
+          <a:p>
+            <a:r>
               <a:t>Because this is a proposal, its claims are on the record now as dated, falsifiable predictions, and they double as the pilot's acceptance tests. Recurrence should cluster around context saturation and compaction, not arrive at random. In a broadly captured corpus, the rate of discovering new failure classes should rise with the corpus's age and size. Mitigation efficacy should be visible as an incidence change across the dated boundary. Without a repository, an incident's true impact should be systematically underestimated, because the cascade is invisible at the moment it occurs. Guardrails upstream of a cause should outperform guardrails at the point of harm. And tightening a system prompt should trade over-refusal against under-refusal. If the deployed record does not show these, we will know, and that is the point.</a:t>
             </a:r>
           </a:p>
@@ -1075,7 +1146,7 @@
           <a:lstStyle/>
           <a:p>
             <a:r>
-              <a:t>The metadata repository is the management vehicle, and it is where the return case lives. It holds four things leadership asks for and cannot get today. An inventory of what AI systems, models, and versions are actually deployed, and by whom. Utilization: how much we use AI, in sessions, tokens, and spend, by team and workflow. Performance and effectiveness: whether the AI is doing useful work, in task success, rework, acceptance, and escalation. And return on investment: the cost we know from the record set against the outcome value we can attribute to AI use, reported at each layer of the objective hierarchy. Inside it, risk and continuity metadata are segregated by sensitivity and governed on their own terms. This is the repository that turns the AI budget from an act of faith into an account.</a:t>
+              <a:t>The metadata repository is the quantitative management vehicle, and it is where the return case lives. It answers what leadership asks and cannot get today, across all of the systems at once. An inventory and user base: what AI systems, models, and versions are deployed, and the tens of thousands of users on them. Utilization and experience: sessions, token consumption, and the user experience and journey, broken down by team and by market segment. Infrastructure: the GPU compute and network the services consume, which is the real cost base of AI at scale. Effectiveness and return: task success and rework, and cost set against attributable value, so the scale and scope of the investment become a number rather than a guess. Inside it, the risk and continuity metadata are segregated by sensitivity and governed on their own terms. This is the repository that turns the AI budget from an act of faith into an account.</a:t>
             </a:r>
           </a:p>
         </p:txBody>
@@ -1145,7 +1216,7 @@
           <a:lstStyle/>
           <a:p>
             <a:r>
-              <a:t>Two reasons this is time-sensitive. First, epistemology. A new failure mode only becomes measurable after enough instances accumulate and someone builds the lens to see it, and both happen after capture. So capture cannot wait on knowing what to look for. And the asymmetry is brutal: capture we omit before a phenomenon emerges cannot be recovered afterward. There is no retrospective study of data nobody wrote down. Capturing now is cheap; reconstructing later is impossible. Second, liability. An AI harm is foreseeable, because a prompt that works today can fail tomorrow; detectable, because the interaction can be examined; and mitigatable, because a caught fault can be corrected before it spreads. An organization that could have foreseen, detected, and mitigated a harm, and did not, because it kept no record, owns the consequence. The record converts a realized loss into a managed event.</a:t>
+              <a:t>The content repository is the other half, and it answers the questions counts cannot. It collects, retains, and sustains the session data of every user-AI session across every service, the prompts, turns, tool calls, and context, as the system of record. Because it preserves what was actually said and done, it is the substrate for qualitative and retrospective work. It is the basis for forensic investigation after a harm event, and for examining, classifying, studying, mitigating, and preventing hallucination behaviors. And from the same content we derive qualitative measures of AI performance by classifying the interactions themselves: what the AI is actually used for, how far it supports each user's work role, and whether the work products people produce with it improve in quality, velocity, scope, completeness, and professionalism. The metadata repository tells us how much and how many; the content repository tells us how well and to what end.</a:t>
             </a:r>
           </a:p>
         </p:txBody>
@@ -1215,7 +1286,7 @@
           <a:lstStyle/>
           <a:p>
             <a:r>
-              <a:t>The same record is the risk and safety substrate. Hallucination is not one thing; we classify it against a taxonomy and manage it on an adverse-event lifecycle borrowed from public health: instance, to tracked incidence, to cause and cascade, to mitigation whose efficacy is measured across a dated boundary, to prevention. And when a harm does occur, the harm is not the end of the event, it opens a required investigation. The record lets us reconstruct the trigger and conditions, attribute the event by separating what the human did from what the AI did, which distinguishes insider misuse, where a person directs the AI against us, from rogue or agentic behavior, where the model itself acts unsafely, and trace how far it spread. The investigation prescribes a guardrail matched to the cause, prompt engineering, a human review gate, workforce training, a permission limit, and because each guardrail is dated, we can prove it worked. This covers the surfaces you named: hallucination, insider threat, rogue behavior, refusal, and forensics.</a:t>
+              <a:t>Two reasons this is time-sensitive. First, epistemology. A new failure mode only becomes measurable after enough instances accumulate and someone builds the lens to see it, and both happen after capture. So capture cannot wait on knowing what to look for. And the asymmetry is brutal: capture we omit before a phenomenon emerges cannot be recovered afterward. There is no retrospective study of data nobody wrote down. Capturing now is cheap; reconstructing later is impossible. Second, liability. An AI harm is foreseeable, because a prompt that works today can fail tomorrow; detectable, because the interaction can be examined; and mitigatable, because a caught fault can be corrected before it spreads. An organization that could have foreseen, detected, and mitigated a harm, and did not, because it kept no record, owns the consequence. The record converts a realized loss into a managed event.</a:t>
             </a:r>
           </a:p>
         </p:txBody>
@@ -1285,7 +1356,7 @@
           <a:lstStyle/>
           <a:p>
             <a:r>
-              <a:t>Two payoffs that matter to a sponsor. First, return becomes an account rather than an anecdote. Cost we know from the record; outcome value we know from the outcome store; return is the relation between them, reported at each layer of the objective hierarchy. The question an executive most wants answered, how far AI multiplies what our people produce, becomes a computed quantity tracked over time. Second, this de-risks the compliance position. The architecture supplies exactly the record that the NIST AI Risk Management Framework, ISO 42001 and 23894, the EU AI Act's logging obligations, and the OWASP LLM Top 10 all presume but do not provide. And governance is built in, not bolted on: stores are segregated by sensitivity, identity is pseudonymous by default so we measure roles and workflows rather than people, and insider-threat monitoring is bounded by purpose, access, and proportionality.</a:t>
+              <a:t>The same record is the risk and safety substrate. Hallucination is not one thing; we classify it against a taxonomy and manage it on an adverse-event lifecycle borrowed from public health: instance, to tracked incidence, to cause and cascade, to mitigation whose efficacy is measured across a dated boundary, to prevention. And when a harm does occur, the harm is not the end of the event, it opens a required investigation. The record lets us reconstruct the trigger and conditions, attribute the event by separating what the human did from what the AI did, which distinguishes insider misuse, where a person directs the AI against us, from rogue or agentic behavior, where the model itself acts unsafely, and trace how far it spread. The investigation prescribes a guardrail matched to the cause, prompt engineering, a human review gate, workforce training, a permission limit, and because each guardrail is dated, we can prove it worked. This covers the surfaces you named: hallucination, insider threat, rogue behavior, refusal, and forensics.</a:t>
             </a:r>
           </a:p>
         </p:txBody>
@@ -1355,7 +1426,7 @@
           <a:lstStyle/>
           <a:p>
             <a:r>
-              <a:t>Here is the ask and the plan. I am proposing [Sponsoring Organization] as the mission sponsor. What I need from the organization is its own data: the inventory of AI systems in use, the objective hierarchy each layer answers to, and the surfaces where AI is used so we know where to instrument. The build is phased and low-risk: stand up the content repository first, because everything depends on capture; derive the metadata repository from it; then add reporting and the return view. We do not boil the ocean, we pilot on one bounded workflow, measure it against its own objectives, and widen only once it earns that. And the paper states dated, falsifiable predictions that become the pilot's acceptance tests, so success or failure is a matter of record, not opinion.</a:t>
+              <a:t>Two payoffs that matter to a sponsor. First, return becomes an account rather than an anecdote. Cost we know from the record; outcome value we know from the outcome store; return is the relation between them, reported at each layer of the objective hierarchy. The question an executive most wants answered, how far AI multiplies what our people produce, becomes a computed quantity tracked over time. Second, this de-risks the compliance position. The architecture supplies exactly the record that the NIST AI Risk Management Framework, ISO 42001 and 23894, the EU AI Act's logging obligations, and the OWASP LLM Top 10 all presume but do not provide. And governance is built in, not bolted on: stores are segregated by sensitivity, identity is pseudonymous by default so we measure roles and workflows rather than people, and insider-threat monitoring is bounded by purpose, access, and proportionality.</a:t>
             </a:r>
           </a:p>
         </p:txBody>
@@ -1425,7 +1496,7 @@
           <a:lstStyle/>
           <a:p>
             <a:r>
-              <a:t>To close, back to the one sentence. An organization cannot manage what it cannot see, and it cannot see its use of AI without a record of that use. Build the two repositories that hold that record and two things become true at once: the harms of AI become foreseeable, detectable, and mitigatable, and the value of AI, including how far it multiplies our people's output, becomes calculable. The same record serves both, so an organization that keeps it can both defend against AI liability and prove its return, and one that does not can do neither. The one property I want to leave you with is that this is time-sensitive: capture we do not start today is capture we can never recover. The ask is simple, and it is to sponsor building the record first.</a:t>
+              <a:t>Here is the ask and the plan. I am proposing [Sponsoring Organization] as the mission sponsor. What I need from the organization is its own data: the inventory of AI systems in use, the objective hierarchy each layer answers to, and the surfaces where AI is used so we know where to instrument. The build is phased and low-risk: stand up the content repository first, because everything depends on capture; derive the metadata repository from it; then add reporting and the return view. We do not boil the ocean, we pilot on one bounded workflow, measure it against its own objectives, and widen only once it earns that. And the paper states dated, falsifiable predictions that become the pilot's acceptance tests, so success or failure is a matter of record, not opinion.</a:t>
             </a:r>
           </a:p>
         </p:txBody>
@@ -4534,8 +4605,8 @@
         </p:nvSpPr>
         <p:spPr>
           <a:xfrm>
-            <a:off x="731520" y="2834640"/>
-            <a:ext cx="10698480" cy="1097280"/>
+            <a:off x="548640" y="320040"/>
+            <a:ext cx="11064240" cy="914400"/>
           </a:xfrm>
           <a:prstGeom prst="rect">
             <a:avLst/>
@@ -4543,30 +4614,106 @@
           <a:noFill/>
         </p:spPr>
         <p:txBody>
-          <a:bodyPr wrap="none">
+          <a:bodyPr wrap="square">
             <a:spAutoFit/>
           </a:bodyPr>
           <a:lstStyle/>
           <a:p>
             <a:r>
-              <a:rPr sz="3400" b="1">
-                <a:solidFill>
-                  <a:srgbClr val="5A636B"/>
+              <a:rPr sz="3000" b="1">
+                <a:solidFill>
+                  <a:srgbClr val="112A46"/>
                 </a:solidFill>
                 <a:latin typeface="Calibri"/>
               </a:rPr>
-              <a:t>Backup material</a:t>
-            </a:r>
-          </a:p>
-          <a:p>
-            <a:r>
-              <a:rPr sz="1500">
-                <a:solidFill>
-                  <a:srgbClr val="1F6F8B"/>
+              <a:t>The ask: build the record first</a:t>
+            </a:r>
+          </a:p>
+        </p:txBody>
+      </p:sp>
+      <p:sp>
+        <p:nvSpPr>
+          <p:cNvPr id="3" name="TextBox 2"/>
+          <p:cNvSpPr txBox="1"/>
+          <p:nvPr/>
+        </p:nvSpPr>
+        <p:spPr>
+          <a:xfrm>
+            <a:off x="640080" y="1554480"/>
+            <a:ext cx="11064240" cy="4846320"/>
+          </a:xfrm>
+          <a:prstGeom prst="rect">
+            <a:avLst/>
+          </a:prstGeom>
+          <a:noFill/>
+        </p:spPr>
+        <p:txBody>
+          <a:bodyPr wrap="square">
+            <a:spAutoFit/>
+          </a:bodyPr>
+          <a:lstStyle/>
+          <a:p>
+            <a:pPr>
+              <a:spcAft>
+                <a:spcPts val="800"/>
+              </a:spcAft>
+            </a:pPr>
+            <a:r>
+              <a:rPr sz="1900">
+                <a:solidFill>
+                  <a:srgbClr val="202428"/>
                 </a:solidFill>
                 <a:latin typeface="Calibri"/>
               </a:rPr>
-              <a:t>Data model  ·  measurement mechanics  ·  hallucination lifecycle  ·  registered predictions</a:t>
+              <a:t>•  On the record, AI harms become foreseeable, detectable, and mitigatable</a:t>
+            </a:r>
+          </a:p>
+          <a:p>
+            <a:pPr>
+              <a:spcAft>
+                <a:spcPts val="800"/>
+              </a:spcAft>
+            </a:pPr>
+            <a:r>
+              <a:rPr sz="1900">
+                <a:solidFill>
+                  <a:srgbClr val="202428"/>
+                </a:solidFill>
+                <a:latin typeface="Calibri"/>
+              </a:rPr>
+              <a:t>•  On the same record, AI's value, including how far it multiplies human capital, becomes calculable</a:t>
+            </a:r>
+          </a:p>
+          <a:p>
+            <a:pPr>
+              <a:spcAft>
+                <a:spcPts val="800"/>
+              </a:spcAft>
+            </a:pPr>
+            <a:r>
+              <a:rPr sz="1900">
+                <a:solidFill>
+                  <a:srgbClr val="202428"/>
+                </a:solidFill>
+                <a:latin typeface="Calibri"/>
+              </a:rPr>
+              <a:t>•  Keep the record and we can both defend against AI liability and prove its return; without it, neither</a:t>
+            </a:r>
+          </a:p>
+          <a:p>
+            <a:pPr lvl="1">
+              <a:spcAft>
+                <a:spcPts val="800"/>
+              </a:spcAft>
+            </a:pPr>
+            <a:r>
+              <a:rPr sz="1700">
+                <a:solidFill>
+                  <a:srgbClr val="5A636B"/>
+                </a:solidFill>
+                <a:latin typeface="Calibri"/>
+              </a:rPr>
+              <a:t>–  Capture now is cheap; reconstruction later is impossible. The decision is time-sensitive.</a:t>
             </a:r>
           </a:p>
         </p:txBody>
@@ -4580,6 +4727,69 @@
 </file>
 
 <file path=ppt/slides/slide11.xml><?xml version="1.0" encoding="utf-8"?>
+<p:sld xmlns:a="http://schemas.openxmlformats.org/drawingml/2006/main" xmlns:p="http://schemas.openxmlformats.org/presentationml/2006/main" xmlns:r="http://schemas.openxmlformats.org/officeDocument/2006/relationships">
+  <p:cSld>
+    <p:spTree>
+      <p:nvGrpSpPr>
+        <p:cNvPr id="1" name=""/>
+        <p:cNvGrpSpPr/>
+        <p:nvPr/>
+      </p:nvGrpSpPr>
+      <p:grpSpPr/>
+      <p:sp>
+        <p:nvSpPr>
+          <p:cNvPr id="2" name="TextBox 1"/>
+          <p:cNvSpPr txBox="1"/>
+          <p:nvPr/>
+        </p:nvSpPr>
+        <p:spPr>
+          <a:xfrm>
+            <a:off x="731520" y="2834640"/>
+            <a:ext cx="10698480" cy="1097280"/>
+          </a:xfrm>
+          <a:prstGeom prst="rect">
+            <a:avLst/>
+          </a:prstGeom>
+          <a:noFill/>
+        </p:spPr>
+        <p:txBody>
+          <a:bodyPr wrap="none">
+            <a:spAutoFit/>
+          </a:bodyPr>
+          <a:lstStyle/>
+          <a:p>
+            <a:r>
+              <a:rPr sz="3400" b="1">
+                <a:solidFill>
+                  <a:srgbClr val="5A636B"/>
+                </a:solidFill>
+                <a:latin typeface="Calibri"/>
+              </a:rPr>
+              <a:t>Backup material</a:t>
+            </a:r>
+          </a:p>
+          <a:p>
+            <a:r>
+              <a:rPr sz="1500">
+                <a:solidFill>
+                  <a:srgbClr val="1F6F8B"/>
+                </a:solidFill>
+                <a:latin typeface="Calibri"/>
+              </a:rPr>
+              <a:t>Data model  ·  measurement mechanics  ·  hallucination lifecycle  ·  registered predictions</a:t>
+            </a:r>
+          </a:p>
+        </p:txBody>
+      </p:sp>
+    </p:spTree>
+  </p:cSld>
+  <p:clrMapOvr>
+    <a:masterClrMapping/>
+  </p:clrMapOvr>
+</p:sld>
+</file>
+
+<file path=ppt/slides/slide12.xml><?xml version="1.0" encoding="utf-8"?>
 <p:sld xmlns:a="http://schemas.openxmlformats.org/drawingml/2006/main" xmlns:p="http://schemas.openxmlformats.org/presentationml/2006/main" xmlns:r="http://schemas.openxmlformats.org/officeDocument/2006/relationships">
   <p:cSld>
     <p:spTree>
@@ -4726,7 +4936,7 @@
 </p:sld>
 </file>
 
-<file path=ppt/slides/slide12.xml><?xml version="1.0" encoding="utf-8"?>
+<file path=ppt/slides/slide13.xml><?xml version="1.0" encoding="utf-8"?>
 <p:sld xmlns:a="http://schemas.openxmlformats.org/drawingml/2006/main" xmlns:p="http://schemas.openxmlformats.org/presentationml/2006/main" xmlns:r="http://schemas.openxmlformats.org/officeDocument/2006/relationships">
   <p:cSld>
     <p:spTree>
@@ -4873,7 +5083,7 @@
 </p:sld>
 </file>
 
-<file path=ppt/slides/slide13.xml><?xml version="1.0" encoding="utf-8"?>
+<file path=ppt/slides/slide14.xml><?xml version="1.0" encoding="utf-8"?>
 <p:sld xmlns:a="http://schemas.openxmlformats.org/drawingml/2006/main" xmlns:p="http://schemas.openxmlformats.org/presentationml/2006/main" xmlns:r="http://schemas.openxmlformats.org/officeDocument/2006/relationships">
   <p:cSld>
     <p:spTree>
@@ -5020,7 +5230,7 @@
 </p:sld>
 </file>
 
-<file path=ppt/slides/slide14.xml><?xml version="1.0" encoding="utf-8"?>
+<file path=ppt/slides/slide15.xml><?xml version="1.0" encoding="utf-8"?>
 <p:sld xmlns:a="http://schemas.openxmlformats.org/drawingml/2006/main" xmlns:p="http://schemas.openxmlformats.org/presentationml/2006/main" xmlns:r="http://schemas.openxmlformats.org/officeDocument/2006/relationships">
   <p:cSld>
     <p:spTree>
@@ -5269,7 +5479,7 @@
                 </a:solidFill>
                 <a:latin typeface="Calibri"/>
               </a:rPr>
-              <a:t>•  A model now drafts replies, writes code, summarizes documents, and helps decide, at scale</a:t>
+              <a:t>•  Adoption is at scale: dozens of purpose-based AI systems serving tens of thousands of users</a:t>
             </a:r>
           </a:p>
           <a:p>
@@ -5285,7 +5495,7 @@
                 </a:solidFill>
                 <a:latin typeface="Calibri"/>
               </a:rPr>
-              <a:t>•  Each interaction is used and then gone: no inventory, no utilization record, no trace of failure</a:t>
+              <a:t>•  A model drafts replies, writes code, summarizes, and helps decide; each interaction is used and then gone</a:t>
             </a:r>
           </a:p>
           <a:p>
@@ -5301,7 +5511,7 @@
                 </a:solidFill>
                 <a:latin typeface="Calibri"/>
               </a:rPr>
-              <a:t>•  We cannot prove the return, and we cannot see the harm, both invisible for the same reason</a:t>
+              <a:t>•  No inventory, no utilization record, no trace of failure: we can prove neither the return nor the harm</a:t>
             </a:r>
           </a:p>
           <a:p>
@@ -5408,7 +5618,7 @@
                 </a:solidFill>
                 <a:latin typeface="Calibri"/>
               </a:rPr>
-              <a:t>•  Content repository: the AI session data itself, preserved as the system of record</a:t>
+              <a:t>•  Metadata repository: quantitative, inventory, utilization, tokens, compute, market segments, ROI</a:t>
             </a:r>
           </a:p>
           <a:p>
@@ -5424,7 +5634,7 @@
                 </a:solidFill>
                 <a:latin typeface="Calibri"/>
               </a:rPr>
-              <a:t>•  Metadata repository: everything derived from it, to manage the AI and prove its return</a:t>
+              <a:t>•  Content repository: qualitative and forensic, every session as the system of record</a:t>
             </a:r>
           </a:p>
           <a:p>
@@ -5440,7 +5650,7 @@
                 </a:solidFill>
                 <a:latin typeface="Calibri"/>
               </a:rPr>
-              <a:t>•  Instrumented systems feed the content repository; reporting draws from the metadata repository</a:t>
+              <a:t>•  Systems feed content; metadata is derived; reporting draws from both</a:t>
             </a:r>
           </a:p>
         </p:txBody>
@@ -5461,8 +5671,8 @@
         </p:blipFill>
         <p:spPr>
           <a:xfrm>
-            <a:off x="518007" y="3200400"/>
-            <a:ext cx="11155680" cy="3182474"/>
+            <a:off x="551696" y="3200400"/>
+            <a:ext cx="11088303" cy="3291840"/>
           </a:xfrm>
           <a:prstGeom prst="rect">
             <a:avLst/>
@@ -5516,7 +5726,7 @@
                 </a:solidFill>
                 <a:latin typeface="Calibri"/>
               </a:rPr>
-              <a:t>The metadata repository: what the investment bought</a:t>
+              <a:t>The metadata repository: the quantitative picture</a:t>
             </a:r>
           </a:p>
         </p:txBody>
@@ -5555,7 +5765,7 @@
                 </a:solidFill>
                 <a:latin typeface="Calibri"/>
               </a:rPr>
-              <a:t>•  Inventory: which AI systems, models, and versions are deployed, and by whom</a:t>
+              <a:t>•  Inventory and user base: which AI systems, models, and versions are deployed, and the users on them</a:t>
             </a:r>
           </a:p>
           <a:p>
@@ -5571,7 +5781,7 @@
                 </a:solidFill>
                 <a:latin typeface="Calibri"/>
               </a:rPr>
-              <a:t>•  Utilization: sessions, tokens, and spend, across teams and workflows</a:t>
+              <a:t>•  Utilization and experience: sessions, token consumption, user experience and journey, by team and market segment</a:t>
             </a:r>
           </a:p>
           <a:p>
@@ -5587,7 +5797,7 @@
                 </a:solidFill>
                 <a:latin typeface="Calibri"/>
               </a:rPr>
-              <a:t>•  Performance and effectiveness: task success, rework, acceptance, escalation</a:t>
+              <a:t>•  Infrastructure: the GPU compute and network the services draw on, the cost base of AI</a:t>
             </a:r>
           </a:p>
           <a:p>
@@ -5603,7 +5813,7 @@
                 </a:solidFill>
                 <a:latin typeface="Calibri"/>
               </a:rPr>
-              <a:t>•  Return on investment: cost from the record against attributable outcome value, per objective layer</a:t>
+              <a:t>•  Effectiveness and return: task success and rework; cost against attributable value; the scale and scope of the investment</a:t>
             </a:r>
           </a:p>
           <a:p>
@@ -5671,7 +5881,7 @@
                 </a:solidFill>
                 <a:latin typeface="Calibri"/>
               </a:rPr>
-              <a:t>Why it must be built now</a:t>
+              <a:t>The content repository: the qualitative and forensic substrate</a:t>
             </a:r>
           </a:p>
         </p:txBody>
@@ -5710,7 +5920,7 @@
                 </a:solidFill>
                 <a:latin typeface="Calibri"/>
               </a:rPr>
-              <a:t>•  The failures worth measuring are not known in advance; capture must precede the question</a:t>
+              <a:t>•  Collects, retains, and sustains every user-AI session across every service, as the system of record</a:t>
             </a:r>
           </a:p>
           <a:p>
@@ -5726,7 +5936,7 @@
                 </a:solidFill>
                 <a:latin typeface="Calibri"/>
               </a:rPr>
-              <a:t>•  Anything not captured before it emerges is unrecoverable: a permanent blind spot</a:t>
+              <a:t>•  The basis for forensic investigation after a harm event, and for studying, mitigating, and preventing hallucination</a:t>
             </a:r>
           </a:p>
           <a:p>
@@ -5742,7 +5952,7 @@
                 </a:solidFill>
                 <a:latin typeface="Calibri"/>
               </a:rPr>
-              <a:t>•  AI harms are foreseeable, detectable, and mitigatable</a:t>
+              <a:t>•  Qualitative measures by classifying the interactions: what the AI is used for, how far it supports each work role</a:t>
             </a:r>
           </a:p>
           <a:p>
@@ -5758,7 +5968,7 @@
                 </a:solidFill>
                 <a:latin typeface="Calibri"/>
               </a:rPr>
-              <a:t>–  A harm we could have caught but did not record is one we own; the record makes it a managed event</a:t>
+              <a:t>–  Whether users' work products improve in quality, velocity, scope, completeness, and professionalism</a:t>
             </a:r>
           </a:p>
         </p:txBody>
@@ -5772,6 +5982,145 @@
 </file>
 
 <file path=ppt/slides/slide6.xml><?xml version="1.0" encoding="utf-8"?>
+<p:sld xmlns:a="http://schemas.openxmlformats.org/drawingml/2006/main" xmlns:p="http://schemas.openxmlformats.org/presentationml/2006/main" xmlns:r="http://schemas.openxmlformats.org/officeDocument/2006/relationships">
+  <p:cSld>
+    <p:spTree>
+      <p:nvGrpSpPr>
+        <p:cNvPr id="1" name=""/>
+        <p:cNvGrpSpPr/>
+        <p:nvPr/>
+      </p:nvGrpSpPr>
+      <p:grpSpPr/>
+      <p:sp>
+        <p:nvSpPr>
+          <p:cNvPr id="2" name="TextBox 1"/>
+          <p:cNvSpPr txBox="1"/>
+          <p:nvPr/>
+        </p:nvSpPr>
+        <p:spPr>
+          <a:xfrm>
+            <a:off x="548640" y="320040"/>
+            <a:ext cx="11064240" cy="914400"/>
+          </a:xfrm>
+          <a:prstGeom prst="rect">
+            <a:avLst/>
+          </a:prstGeom>
+          <a:noFill/>
+        </p:spPr>
+        <p:txBody>
+          <a:bodyPr wrap="square">
+            <a:spAutoFit/>
+          </a:bodyPr>
+          <a:lstStyle/>
+          <a:p>
+            <a:r>
+              <a:rPr sz="3000" b="1">
+                <a:solidFill>
+                  <a:srgbClr val="112A46"/>
+                </a:solidFill>
+                <a:latin typeface="Calibri"/>
+              </a:rPr>
+              <a:t>Why it must be built now</a:t>
+            </a:r>
+          </a:p>
+        </p:txBody>
+      </p:sp>
+      <p:sp>
+        <p:nvSpPr>
+          <p:cNvPr id="3" name="TextBox 2"/>
+          <p:cNvSpPr txBox="1"/>
+          <p:nvPr/>
+        </p:nvSpPr>
+        <p:spPr>
+          <a:xfrm>
+            <a:off x="640080" y="1554480"/>
+            <a:ext cx="11064240" cy="4846320"/>
+          </a:xfrm>
+          <a:prstGeom prst="rect">
+            <a:avLst/>
+          </a:prstGeom>
+          <a:noFill/>
+        </p:spPr>
+        <p:txBody>
+          <a:bodyPr wrap="square">
+            <a:spAutoFit/>
+          </a:bodyPr>
+          <a:lstStyle/>
+          <a:p>
+            <a:pPr>
+              <a:spcAft>
+                <a:spcPts val="800"/>
+              </a:spcAft>
+            </a:pPr>
+            <a:r>
+              <a:rPr sz="1900">
+                <a:solidFill>
+                  <a:srgbClr val="202428"/>
+                </a:solidFill>
+                <a:latin typeface="Calibri"/>
+              </a:rPr>
+              <a:t>•  The failures worth measuring are not known in advance; capture must precede the question</a:t>
+            </a:r>
+          </a:p>
+          <a:p>
+            <a:pPr>
+              <a:spcAft>
+                <a:spcPts val="800"/>
+              </a:spcAft>
+            </a:pPr>
+            <a:r>
+              <a:rPr sz="1900">
+                <a:solidFill>
+                  <a:srgbClr val="202428"/>
+                </a:solidFill>
+                <a:latin typeface="Calibri"/>
+              </a:rPr>
+              <a:t>•  Anything not captured before it emerges is unrecoverable: a permanent blind spot</a:t>
+            </a:r>
+          </a:p>
+          <a:p>
+            <a:pPr>
+              <a:spcAft>
+                <a:spcPts val="800"/>
+              </a:spcAft>
+            </a:pPr>
+            <a:r>
+              <a:rPr sz="1900">
+                <a:solidFill>
+                  <a:srgbClr val="202428"/>
+                </a:solidFill>
+                <a:latin typeface="Calibri"/>
+              </a:rPr>
+              <a:t>•  AI harms are foreseeable, detectable, and mitigatable</a:t>
+            </a:r>
+          </a:p>
+          <a:p>
+            <a:pPr lvl="1">
+              <a:spcAft>
+                <a:spcPts val="800"/>
+              </a:spcAft>
+            </a:pPr>
+            <a:r>
+              <a:rPr sz="1700">
+                <a:solidFill>
+                  <a:srgbClr val="5A636B"/>
+                </a:solidFill>
+                <a:latin typeface="Calibri"/>
+              </a:rPr>
+              <a:t>–  A harm we could have caught but did not record is one we own; the record makes it a managed event</a:t>
+            </a:r>
+          </a:p>
+        </p:txBody>
+      </p:sp>
+    </p:spTree>
+  </p:cSld>
+  <p:clrMapOvr>
+    <a:masterClrMapping/>
+  </p:clrMapOvr>
+</p:sld>
+</file>
+
+<file path=ppt/slides/slide7.xml><?xml version="1.0" encoding="utf-8"?>
 <p:sld xmlns:a="http://schemas.openxmlformats.org/drawingml/2006/main" xmlns:p="http://schemas.openxmlformats.org/presentationml/2006/main" xmlns:r="http://schemas.openxmlformats.org/officeDocument/2006/relationships">
   <p:cSld>
     <p:spTree>
@@ -5918,7 +6267,7 @@
 </p:sld>
 </file>
 
-<file path=ppt/slides/slide7.xml><?xml version="1.0" encoding="utf-8"?>
+<file path=ppt/slides/slide8.xml><?xml version="1.0" encoding="utf-8"?>
 <p:sld xmlns:a="http://schemas.openxmlformats.org/drawingml/2006/main" xmlns:p="http://schemas.openxmlformats.org/presentationml/2006/main" xmlns:r="http://schemas.openxmlformats.org/officeDocument/2006/relationships">
   <p:cSld>
     <p:spTree>
@@ -6045,161 +6394,6 @@
                 <a:latin typeface="Calibri"/>
               </a:rPr>
               <a:t>–  Governed by design: segregation by sensitivity, pseudonymous identity, bounded monitoring</a:t>
-            </a:r>
-          </a:p>
-        </p:txBody>
-      </p:sp>
-    </p:spTree>
-  </p:cSld>
-  <p:clrMapOvr>
-    <a:masterClrMapping/>
-  </p:clrMapOvr>
-</p:sld>
-</file>
-
-<file path=ppt/slides/slide8.xml><?xml version="1.0" encoding="utf-8"?>
-<p:sld xmlns:a="http://schemas.openxmlformats.org/drawingml/2006/main" xmlns:p="http://schemas.openxmlformats.org/presentationml/2006/main" xmlns:r="http://schemas.openxmlformats.org/officeDocument/2006/relationships">
-  <p:cSld>
-    <p:spTree>
-      <p:nvGrpSpPr>
-        <p:cNvPr id="1" name=""/>
-        <p:cNvGrpSpPr/>
-        <p:nvPr/>
-      </p:nvGrpSpPr>
-      <p:grpSpPr/>
-      <p:sp>
-        <p:nvSpPr>
-          <p:cNvPr id="2" name="TextBox 1"/>
-          <p:cNvSpPr txBox="1"/>
-          <p:nvPr/>
-        </p:nvSpPr>
-        <p:spPr>
-          <a:xfrm>
-            <a:off x="548640" y="320040"/>
-            <a:ext cx="11064240" cy="914400"/>
-          </a:xfrm>
-          <a:prstGeom prst="rect">
-            <a:avLst/>
-          </a:prstGeom>
-          <a:noFill/>
-        </p:spPr>
-        <p:txBody>
-          <a:bodyPr wrap="square">
-            <a:spAutoFit/>
-          </a:bodyPr>
-          <a:lstStyle/>
-          <a:p>
-            <a:r>
-              <a:rPr sz="3000" b="1">
-                <a:solidFill>
-                  <a:srgbClr val="112A46"/>
-                </a:solidFill>
-                <a:latin typeface="Calibri"/>
-              </a:rPr>
-              <a:t>Mission sponsor and next steps</a:t>
-            </a:r>
-          </a:p>
-        </p:txBody>
-      </p:sp>
-      <p:sp>
-        <p:nvSpPr>
-          <p:cNvPr id="3" name="TextBox 2"/>
-          <p:cNvSpPr txBox="1"/>
-          <p:nvPr/>
-        </p:nvSpPr>
-        <p:spPr>
-          <a:xfrm>
-            <a:off x="640080" y="1554480"/>
-            <a:ext cx="11064240" cy="4846320"/>
-          </a:xfrm>
-          <a:prstGeom prst="rect">
-            <a:avLst/>
-          </a:prstGeom>
-          <a:noFill/>
-        </p:spPr>
-        <p:txBody>
-          <a:bodyPr wrap="square">
-            <a:spAutoFit/>
-          </a:bodyPr>
-          <a:lstStyle/>
-          <a:p>
-            <a:pPr>
-              <a:spcAft>
-                <a:spcPts val="800"/>
-              </a:spcAft>
-            </a:pPr>
-            <a:r>
-              <a:rPr sz="1900">
-                <a:solidFill>
-                  <a:srgbClr val="202428"/>
-                </a:solidFill>
-                <a:latin typeface="Calibri"/>
-              </a:rPr>
-              <a:t>•  Proposed for [Sponsoring Organization] as mission sponsor</a:t>
-            </a:r>
-          </a:p>
-          <a:p>
-            <a:pPr>
-              <a:spcAft>
-                <a:spcPts val="800"/>
-              </a:spcAft>
-            </a:pPr>
-            <a:r>
-              <a:rPr sz="1900">
-                <a:solidFill>
-                  <a:srgbClr val="202428"/>
-                </a:solidFill>
-                <a:latin typeface="Calibri"/>
-              </a:rPr>
-              <a:t>•  Organization data to provide: AI systems inventory, objective hierarchy, deployment surfaces</a:t>
-            </a:r>
-          </a:p>
-          <a:p>
-            <a:pPr>
-              <a:spcAft>
-                <a:spcPts val="800"/>
-              </a:spcAft>
-            </a:pPr>
-            <a:r>
-              <a:rPr sz="1900">
-                <a:solidFill>
-                  <a:srgbClr val="202428"/>
-                </a:solidFill>
-                <a:latin typeface="Calibri"/>
-              </a:rPr>
-              <a:t>•  Phased build: content repository first, then metadata derivation, then reporting and ROI</a:t>
-            </a:r>
-          </a:p>
-          <a:p>
-            <a:pPr>
-              <a:spcAft>
-                <a:spcPts val="800"/>
-              </a:spcAft>
-            </a:pPr>
-            <a:r>
-              <a:rPr sz="1900">
-                <a:solidFill>
-                  <a:srgbClr val="202428"/>
-                </a:solidFill>
-                <a:latin typeface="Calibri"/>
-              </a:rPr>
-              <a:t>•  Pilot on one bounded workflow, measure against its objectives, then widen</a:t>
-            </a:r>
-          </a:p>
-          <a:p>
-            <a:pPr lvl="1">
-              <a:spcAft>
-                <a:spcPts val="800"/>
-              </a:spcAft>
-            </a:pPr>
-            <a:r>
-              <a:rPr sz="1700">
-                <a:solidFill>
-                  <a:srgbClr val="5A636B"/>
-                </a:solidFill>
-                <a:latin typeface="Calibri"/>
-              </a:rPr>
-              <a:t>–  The paper's dated, falsifiable predictions become the acceptance tests for the pilot</a:t>
             </a:r>
           </a:p>
         </p:txBody>
@@ -6251,7 +6445,7 @@
                 </a:solidFill>
                 <a:latin typeface="Calibri"/>
               </a:rPr>
-              <a:t>The ask: build the record first</a:t>
+              <a:t>Mission sponsor and next steps</a:t>
             </a:r>
           </a:p>
         </p:txBody>
@@ -6290,7 +6484,7 @@
                 </a:solidFill>
                 <a:latin typeface="Calibri"/>
               </a:rPr>
-              <a:t>•  On the record, AI harms become foreseeable, detectable, and mitigatable</a:t>
+              <a:t>•  Proposed for [Sponsoring Organization] as mission sponsor</a:t>
             </a:r>
           </a:p>
           <a:p>
@@ -6306,7 +6500,7 @@
                 </a:solidFill>
                 <a:latin typeface="Calibri"/>
               </a:rPr>
-              <a:t>•  On the same record, AI's value, including how far it multiplies human capital, becomes calculable</a:t>
+              <a:t>•  Organization data to provide: AI systems inventory, objective hierarchy, deployment surfaces</a:t>
             </a:r>
           </a:p>
           <a:p>
@@ -6322,7 +6516,23 @@
                 </a:solidFill>
                 <a:latin typeface="Calibri"/>
               </a:rPr>
-              <a:t>•  Keep the record and we can both defend against AI liability and prove its return; without it, neither</a:t>
+              <a:t>•  Phased build: content repository first, then metadata derivation, then reporting and ROI</a:t>
+            </a:r>
+          </a:p>
+          <a:p>
+            <a:pPr>
+              <a:spcAft>
+                <a:spcPts val="800"/>
+              </a:spcAft>
+            </a:pPr>
+            <a:r>
+              <a:rPr sz="1900">
+                <a:solidFill>
+                  <a:srgbClr val="202428"/>
+                </a:solidFill>
+                <a:latin typeface="Calibri"/>
+              </a:rPr>
+              <a:t>•  Pilot on one bounded workflow, measure against its objectives, then widen</a:t>
             </a:r>
           </a:p>
           <a:p>
@@ -6338,7 +6548,7 @@
                 </a:solidFill>
                 <a:latin typeface="Calibri"/>
               </a:rPr>
-              <a:t>–  Capture now is cheap; reconstruction later is impossible. The decision is time-sensitive.</a:t>
+              <a:t>–  The paper's dated, falsifiable predictions become the acceptance tests for the pilot</a:t>
             </a:r>
           </a:p>
         </p:txBody>

</xml_diff>